<commit_message>
Updated Professional Networking Service v1 Lean Business Case
</commit_message>
<xml_diff>
--- a/docs/2_Value_Creation/2a_Product/Professional Networking/Professional Networking v1 Lean Business Case.pptx
+++ b/docs/2_Value_Creation/2a_Product/Professional Networking/Professional Networking v1 Lean Business Case.pptx
@@ -261,45 +261,29 @@
       <p15:sldGuideLst xmlns:p15="http://schemas.microsoft.com/office/powerpoint/2012/main"/>
     </p:ext>
     <p:ext uri="GoogleSlidesCustomDataVersion2">
-      <go:slidesCustomData xmlns="" xmlns:mc="http://schemas.openxmlformats.org/markup-compatibility/2006" xmlns:mv="urn:schemas-microsoft-com:mac:vml" xmlns:c="http://schemas.openxmlformats.org/drawingml/2006/chart" xmlns:dgm="http://schemas.openxmlformats.org/drawingml/2006/diagram" xmlns:o="urn:schemas-microsoft-com:office:office" xmlns:v="urn:schemas-microsoft-com:vml" xmlns:pvml="urn:schemas-microsoft-com:office:powerpoint" xmlns:com="http://schemas.openxmlformats.org/drawingml/2006/compatibility" xmlns:p14="http://schemas.microsoft.com/office/powerpoint/2010/main" xmlns:p15="http://schemas.microsoft.com/office/powerpoint/2012/main" xmlns:ahyp="http://schemas.microsoft.com/office/drawing/2018/hyperlinkcolor" xmlns:go="http://customooxmlschemas.google.com/" r:id="rId19" roundtripDataSignature="AMtx7mhwEp+Eio5qReXqYqUwMP31HB0A8A=="/>
+      <go:slidesCustomData xmlns:go="http://customooxmlschemas.google.com/" xmlns:ahyp="http://schemas.microsoft.com/office/drawing/2018/hyperlinkcolor" xmlns:p15="http://schemas.microsoft.com/office/powerpoint/2012/main" xmlns:p14="http://schemas.microsoft.com/office/powerpoint/2010/main" xmlns:com="http://schemas.openxmlformats.org/drawingml/2006/compatibility" xmlns:pvml="urn:schemas-microsoft-com:office:powerpoint" xmlns:v="urn:schemas-microsoft-com:vml" xmlns:o="urn:schemas-microsoft-com:office:office" xmlns:dgm="http://schemas.openxmlformats.org/drawingml/2006/diagram" xmlns:c="http://schemas.openxmlformats.org/drawingml/2006/chart" xmlns:mv="urn:schemas-microsoft-com:mac:vml" xmlns:mc="http://schemas.openxmlformats.org/markup-compatibility/2006" xmlns="" r:id="rId19" roundtripDataSignature="AMtx7mhwEp+Eio5qReXqYqUwMP31HB0A8A=="/>
     </p:ext>
   </p:extLst>
 </p:presentation>
 </file>
 
-<file path=ppt/revisionInfo.xml><?xml version="1.0" encoding="utf-8"?>
-<p1510:revInfo xmlns:a="http://schemas.openxmlformats.org/drawingml/2006/main" xmlns:r="http://schemas.openxmlformats.org/officeDocument/2006/relationships" xmlns:p1510="http://schemas.microsoft.com/office/powerpoint/2015/10/main">
-  <p1510:revLst>
-    <p1510:client id="{4AB8F1AF-C3AC-A441-B0A6-C34DB2CDE3D6}" v="46" dt="2024-11-01T19:12:20.612"/>
-  </p1510:revLst>
-</p1510:revInfo>
-</file>
-
 <file path=ppt/changesInfos/changesInfo1.xml><?xml version="1.0" encoding="utf-8"?>
 <pc:chgInfo xmlns:a="http://schemas.openxmlformats.org/drawingml/2006/main" xmlns:r="http://schemas.openxmlformats.org/officeDocument/2006/relationships" xmlns:ac="http://schemas.microsoft.com/office/drawing/2013/main/command" xmlns:pc="http://schemas.microsoft.com/office/powerpoint/2013/main/command">
   <pc:docChgLst>
-    <pc:chgData name="Rich Reba" userId="8245d172-5b81-40f1-a13b-b71f02cd6700" providerId="ADAL" clId="{4AB8F1AF-C3AC-A441-B0A6-C34DB2CDE3D6}"/>
-    <pc:docChg chg="undo custSel addSld delSld modSld">
-      <pc:chgData name="Rich Reba" userId="8245d172-5b81-40f1-a13b-b71f02cd6700" providerId="ADAL" clId="{4AB8F1AF-C3AC-A441-B0A6-C34DB2CDE3D6}" dt="2024-11-01T20:28:33.321" v="2240" actId="20577"/>
+    <pc:chgData name="Rich Reba" userId="55db41ab6eb3f845" providerId="LiveId" clId="{0E19DA16-244C-5B50-BE0F-52911DD4CA7E}"/>
+    <pc:docChg chg="custSel modSld">
+      <pc:chgData name="Rich Reba" userId="55db41ab6eb3f845" providerId="LiveId" clId="{0E19DA16-244C-5B50-BE0F-52911DD4CA7E}" dt="2026-08-09T19:25:47.601" v="718" actId="20577"/>
       <pc:docMkLst>
         <pc:docMk/>
       </pc:docMkLst>
       <pc:sldChg chg="modSp mod">
-        <pc:chgData name="Rich Reba" userId="8245d172-5b81-40f1-a13b-b71f02cd6700" providerId="ADAL" clId="{4AB8F1AF-C3AC-A441-B0A6-C34DB2CDE3D6}" dt="2024-11-01T19:03:11.591" v="2036" actId="14100"/>
+        <pc:chgData name="Rich Reba" userId="55db41ab6eb3f845" providerId="LiveId" clId="{0E19DA16-244C-5B50-BE0F-52911DD4CA7E}" dt="2026-08-09T19:25:47.601" v="718" actId="20577"/>
         <pc:sldMkLst>
           <pc:docMk/>
           <pc:sldMk cId="0" sldId="256"/>
         </pc:sldMkLst>
         <pc:spChg chg="mod">
-          <ac:chgData name="Rich Reba" userId="8245d172-5b81-40f1-a13b-b71f02cd6700" providerId="ADAL" clId="{4AB8F1AF-C3AC-A441-B0A6-C34DB2CDE3D6}" dt="2024-11-01T19:03:11.591" v="2036" actId="14100"/>
-          <ac:spMkLst>
-            <pc:docMk/>
-            <pc:sldMk cId="0" sldId="256"/>
-            <ac:spMk id="90" creationId="{00000000-0000-0000-0000-000000000000}"/>
-          </ac:spMkLst>
-        </pc:spChg>
-        <pc:spChg chg="mod">
-          <ac:chgData name="Rich Reba" userId="8245d172-5b81-40f1-a13b-b71f02cd6700" providerId="ADAL" clId="{4AB8F1AF-C3AC-A441-B0A6-C34DB2CDE3D6}" dt="2024-11-01T17:57:22.557" v="1990" actId="20577"/>
+          <ac:chgData name="Rich Reba" userId="55db41ab6eb3f845" providerId="LiveId" clId="{0E19DA16-244C-5B50-BE0F-52911DD4CA7E}" dt="2026-08-09T19:25:47.601" v="718" actId="20577"/>
           <ac:spMkLst>
             <pc:docMk/>
             <pc:sldMk cId="0" sldId="256"/>
@@ -308,29 +292,13 @@
         </pc:spChg>
       </pc:sldChg>
       <pc:sldChg chg="modSp mod">
-        <pc:chgData name="Rich Reba" userId="8245d172-5b81-40f1-a13b-b71f02cd6700" providerId="ADAL" clId="{4AB8F1AF-C3AC-A441-B0A6-C34DB2CDE3D6}" dt="2024-10-25T17:51:14.153" v="1964" actId="20577"/>
+        <pc:chgData name="Rich Reba" userId="55db41ab6eb3f845" providerId="LiveId" clId="{0E19DA16-244C-5B50-BE0F-52911DD4CA7E}" dt="2026-08-09T19:14:42.756" v="72" actId="20577"/>
         <pc:sldMkLst>
           <pc:docMk/>
           <pc:sldMk cId="1272635936" sldId="264"/>
         </pc:sldMkLst>
-        <pc:spChg chg="mod">
-          <ac:chgData name="Rich Reba" userId="8245d172-5b81-40f1-a13b-b71f02cd6700" providerId="ADAL" clId="{4AB8F1AF-C3AC-A441-B0A6-C34DB2CDE3D6}" dt="2024-10-23T20:50:12.126" v="314" actId="1035"/>
-          <ac:spMkLst>
-            <pc:docMk/>
-            <pc:sldMk cId="1272635936" sldId="264"/>
-            <ac:spMk id="6" creationId="{F57F7845-FD8A-DCA4-39DB-1B7D9CF0BA2A}"/>
-          </ac:spMkLst>
-        </pc:spChg>
-        <pc:spChg chg="mod">
-          <ac:chgData name="Rich Reba" userId="8245d172-5b81-40f1-a13b-b71f02cd6700" providerId="ADAL" clId="{4AB8F1AF-C3AC-A441-B0A6-C34DB2CDE3D6}" dt="2024-10-23T20:41:31.439" v="101" actId="20577"/>
-          <ac:spMkLst>
-            <pc:docMk/>
-            <pc:sldMk cId="1272635936" sldId="264"/>
-            <ac:spMk id="96" creationId="{00000000-0000-0000-0000-000000000000}"/>
-          </ac:spMkLst>
-        </pc:spChg>
-        <pc:graphicFrameChg chg="mod modGraphic">
-          <ac:chgData name="Rich Reba" userId="8245d172-5b81-40f1-a13b-b71f02cd6700" providerId="ADAL" clId="{4AB8F1AF-C3AC-A441-B0A6-C34DB2CDE3D6}" dt="2024-10-25T17:51:14.153" v="1964" actId="20577"/>
+        <pc:graphicFrameChg chg="modGraphic">
+          <ac:chgData name="Rich Reba" userId="55db41ab6eb3f845" providerId="LiveId" clId="{0E19DA16-244C-5B50-BE0F-52911DD4CA7E}" dt="2026-08-09T19:14:42.756" v="72" actId="20577"/>
           <ac:graphicFrameMkLst>
             <pc:docMk/>
             <pc:sldMk cId="1272635936" sldId="264"/>
@@ -338,30 +306,14 @@
           </ac:graphicFrameMkLst>
         </pc:graphicFrameChg>
       </pc:sldChg>
-      <pc:sldChg chg="addSp modSp mod">
-        <pc:chgData name="Rich Reba" userId="8245d172-5b81-40f1-a13b-b71f02cd6700" providerId="ADAL" clId="{4AB8F1AF-C3AC-A441-B0A6-C34DB2CDE3D6}" dt="2024-10-24T17:32:42.305" v="763" actId="1036"/>
+      <pc:sldChg chg="modSp mod">
+        <pc:chgData name="Rich Reba" userId="55db41ab6eb3f845" providerId="LiveId" clId="{0E19DA16-244C-5B50-BE0F-52911DD4CA7E}" dt="2026-08-09T19:15:26.765" v="158" actId="20577"/>
         <pc:sldMkLst>
           <pc:docMk/>
           <pc:sldMk cId="4188122143" sldId="266"/>
         </pc:sldMkLst>
-        <pc:spChg chg="mod">
-          <ac:chgData name="Rich Reba" userId="8245d172-5b81-40f1-a13b-b71f02cd6700" providerId="ADAL" clId="{4AB8F1AF-C3AC-A441-B0A6-C34DB2CDE3D6}" dt="2024-10-24T17:32:42.305" v="763" actId="1036"/>
-          <ac:spMkLst>
-            <pc:docMk/>
-            <pc:sldMk cId="4188122143" sldId="266"/>
-            <ac:spMk id="5" creationId="{C5748C3E-8A70-958C-B8E4-332FC5861BB3}"/>
-          </ac:spMkLst>
-        </pc:spChg>
-        <pc:spChg chg="add mod">
-          <ac:chgData name="Rich Reba" userId="8245d172-5b81-40f1-a13b-b71f02cd6700" providerId="ADAL" clId="{4AB8F1AF-C3AC-A441-B0A6-C34DB2CDE3D6}" dt="2024-10-24T17:32:35.348" v="758" actId="1036"/>
-          <ac:spMkLst>
-            <pc:docMk/>
-            <pc:sldMk cId="4188122143" sldId="266"/>
-            <ac:spMk id="7" creationId="{9D6D51B8-EAEB-EAC5-1B5E-A8C3E5DDAE00}"/>
-          </ac:spMkLst>
-        </pc:spChg>
-        <pc:graphicFrameChg chg="mod modGraphic">
-          <ac:chgData name="Rich Reba" userId="8245d172-5b81-40f1-a13b-b71f02cd6700" providerId="ADAL" clId="{4AB8F1AF-C3AC-A441-B0A6-C34DB2CDE3D6}" dt="2024-10-24T17:32:22.068" v="745"/>
+        <pc:graphicFrameChg chg="modGraphic">
+          <ac:chgData name="Rich Reba" userId="55db41ab6eb3f845" providerId="LiveId" clId="{0E19DA16-244C-5B50-BE0F-52911DD4CA7E}" dt="2026-08-09T19:15:26.765" v="158" actId="20577"/>
           <ac:graphicFrameMkLst>
             <pc:docMk/>
             <pc:sldMk cId="4188122143" sldId="266"/>
@@ -370,13 +322,13 @@
         </pc:graphicFrameChg>
       </pc:sldChg>
       <pc:sldChg chg="modSp mod">
-        <pc:chgData name="Rich Reba" userId="8245d172-5b81-40f1-a13b-b71f02cd6700" providerId="ADAL" clId="{4AB8F1AF-C3AC-A441-B0A6-C34DB2CDE3D6}" dt="2024-11-01T17:57:14.343" v="1980" actId="20577"/>
+        <pc:chgData name="Rich Reba" userId="55db41ab6eb3f845" providerId="LiveId" clId="{0E19DA16-244C-5B50-BE0F-52911DD4CA7E}" dt="2026-08-09T19:23:00.108" v="652" actId="20577"/>
         <pc:sldMkLst>
           <pc:docMk/>
           <pc:sldMk cId="1243007551" sldId="268"/>
         </pc:sldMkLst>
-        <pc:graphicFrameChg chg="mod modGraphic">
-          <ac:chgData name="Rich Reba" userId="8245d172-5b81-40f1-a13b-b71f02cd6700" providerId="ADAL" clId="{4AB8F1AF-C3AC-A441-B0A6-C34DB2CDE3D6}" dt="2024-11-01T17:57:14.343" v="1980" actId="20577"/>
+        <pc:graphicFrameChg chg="modGraphic">
+          <ac:chgData name="Rich Reba" userId="55db41ab6eb3f845" providerId="LiveId" clId="{0E19DA16-244C-5B50-BE0F-52911DD4CA7E}" dt="2026-08-09T19:23:00.108" v="652" actId="20577"/>
           <ac:graphicFrameMkLst>
             <pc:docMk/>
             <pc:sldMk cId="1243007551" sldId="268"/>
@@ -385,13 +337,13 @@
         </pc:graphicFrameChg>
       </pc:sldChg>
       <pc:sldChg chg="modSp mod">
-        <pc:chgData name="Rich Reba" userId="8245d172-5b81-40f1-a13b-b71f02cd6700" providerId="ADAL" clId="{4AB8F1AF-C3AC-A441-B0A6-C34DB2CDE3D6}" dt="2024-11-01T19:13:23.009" v="2231" actId="20577"/>
+        <pc:chgData name="Rich Reba" userId="55db41ab6eb3f845" providerId="LiveId" clId="{0E19DA16-244C-5B50-BE0F-52911DD4CA7E}" dt="2026-08-09T19:18:38.979" v="405" actId="20577"/>
         <pc:sldMkLst>
           <pc:docMk/>
           <pc:sldMk cId="450257364" sldId="269"/>
         </pc:sldMkLst>
-        <pc:graphicFrameChg chg="mod modGraphic">
-          <ac:chgData name="Rich Reba" userId="8245d172-5b81-40f1-a13b-b71f02cd6700" providerId="ADAL" clId="{4AB8F1AF-C3AC-A441-B0A6-C34DB2CDE3D6}" dt="2024-11-01T19:13:23.009" v="2231" actId="20577"/>
+        <pc:graphicFrameChg chg="modGraphic">
+          <ac:chgData name="Rich Reba" userId="55db41ab6eb3f845" providerId="LiveId" clId="{0E19DA16-244C-5B50-BE0F-52911DD4CA7E}" dt="2026-08-09T19:18:38.979" v="405" actId="20577"/>
           <ac:graphicFrameMkLst>
             <pc:docMk/>
             <pc:sldMk cId="450257364" sldId="269"/>
@@ -400,13 +352,13 @@
         </pc:graphicFrameChg>
       </pc:sldChg>
       <pc:sldChg chg="modSp mod">
-        <pc:chgData name="Rich Reba" userId="8245d172-5b81-40f1-a13b-b71f02cd6700" providerId="ADAL" clId="{4AB8F1AF-C3AC-A441-B0A6-C34DB2CDE3D6}" dt="2024-11-01T18:55:09.390" v="2024" actId="20577"/>
+        <pc:chgData name="Rich Reba" userId="55db41ab6eb3f845" providerId="LiveId" clId="{0E19DA16-244C-5B50-BE0F-52911DD4CA7E}" dt="2026-08-09T19:21:32.870" v="556" actId="20577"/>
         <pc:sldMkLst>
           <pc:docMk/>
           <pc:sldMk cId="4255637138" sldId="270"/>
         </pc:sldMkLst>
-        <pc:graphicFrameChg chg="mod modGraphic">
-          <ac:chgData name="Rich Reba" userId="8245d172-5b81-40f1-a13b-b71f02cd6700" providerId="ADAL" clId="{4AB8F1AF-C3AC-A441-B0A6-C34DB2CDE3D6}" dt="2024-11-01T18:55:09.390" v="2024" actId="20577"/>
+        <pc:graphicFrameChg chg="modGraphic">
+          <ac:chgData name="Rich Reba" userId="55db41ab6eb3f845" providerId="LiveId" clId="{0E19DA16-244C-5B50-BE0F-52911DD4CA7E}" dt="2026-08-09T19:21:32.870" v="556" actId="20577"/>
           <ac:graphicFrameMkLst>
             <pc:docMk/>
             <pc:sldMk cId="4255637138" sldId="270"/>
@@ -415,13 +367,13 @@
         </pc:graphicFrameChg>
       </pc:sldChg>
       <pc:sldChg chg="modSp mod">
-        <pc:chgData name="Rich Reba" userId="8245d172-5b81-40f1-a13b-b71f02cd6700" providerId="ADAL" clId="{4AB8F1AF-C3AC-A441-B0A6-C34DB2CDE3D6}" dt="2024-11-01T20:28:33.321" v="2240" actId="20577"/>
+        <pc:chgData name="Rich Reba" userId="55db41ab6eb3f845" providerId="LiveId" clId="{0E19DA16-244C-5B50-BE0F-52911DD4CA7E}" dt="2026-08-09T19:24:10.574" v="667" actId="20577"/>
         <pc:sldMkLst>
           <pc:docMk/>
           <pc:sldMk cId="67448461" sldId="271"/>
         </pc:sldMkLst>
-        <pc:graphicFrameChg chg="mod modGraphic">
-          <ac:chgData name="Rich Reba" userId="8245d172-5b81-40f1-a13b-b71f02cd6700" providerId="ADAL" clId="{4AB8F1AF-C3AC-A441-B0A6-C34DB2CDE3D6}" dt="2024-11-01T20:28:33.321" v="2240" actId="20577"/>
+        <pc:graphicFrameChg chg="modGraphic">
+          <ac:chgData name="Rich Reba" userId="55db41ab6eb3f845" providerId="LiveId" clId="{0E19DA16-244C-5B50-BE0F-52911DD4CA7E}" dt="2026-08-09T19:24:10.574" v="667" actId="20577"/>
           <ac:graphicFrameMkLst>
             <pc:docMk/>
             <pc:sldMk cId="67448461" sldId="271"/>
@@ -430,862 +382,13 @@
         </pc:graphicFrameChg>
       </pc:sldChg>
       <pc:sldChg chg="modSp mod">
-        <pc:chgData name="Rich Reba" userId="8245d172-5b81-40f1-a13b-b71f02cd6700" providerId="ADAL" clId="{4AB8F1AF-C3AC-A441-B0A6-C34DB2CDE3D6}" dt="2024-10-24T18:14:27.786" v="1751" actId="20577"/>
-        <pc:sldMkLst>
-          <pc:docMk/>
-          <pc:sldMk cId="3088802820" sldId="272"/>
-        </pc:sldMkLst>
-        <pc:graphicFrameChg chg="mod modGraphic">
-          <ac:chgData name="Rich Reba" userId="8245d172-5b81-40f1-a13b-b71f02cd6700" providerId="ADAL" clId="{4AB8F1AF-C3AC-A441-B0A6-C34DB2CDE3D6}" dt="2024-10-24T18:14:27.786" v="1751" actId="20577"/>
-          <ac:graphicFrameMkLst>
-            <pc:docMk/>
-            <pc:sldMk cId="3088802820" sldId="272"/>
-            <ac:graphicFrameMk id="3" creationId="{F1699409-9005-50C8-4771-BC86CF9F9048}"/>
-          </ac:graphicFrameMkLst>
-        </pc:graphicFrameChg>
-      </pc:sldChg>
-      <pc:sldChg chg="del">
-        <pc:chgData name="Rich Reba" userId="8245d172-5b81-40f1-a13b-b71f02cd6700" providerId="ADAL" clId="{4AB8F1AF-C3AC-A441-B0A6-C34DB2CDE3D6}" dt="2024-10-22T01:11:46.023" v="5" actId="2696"/>
-        <pc:sldMkLst>
-          <pc:docMk/>
-          <pc:sldMk cId="3864669982" sldId="274"/>
-        </pc:sldMkLst>
-      </pc:sldChg>
-      <pc:sldChg chg="addSp delSp modSp mod">
-        <pc:chgData name="Rich Reba" userId="8245d172-5b81-40f1-a13b-b71f02cd6700" providerId="ADAL" clId="{4AB8F1AF-C3AC-A441-B0A6-C34DB2CDE3D6}" dt="2024-10-24T18:25:07.175" v="1924" actId="20577"/>
-        <pc:sldMkLst>
-          <pc:docMk/>
-          <pc:sldMk cId="2639682451" sldId="275"/>
-        </pc:sldMkLst>
-        <pc:spChg chg="mod">
-          <ac:chgData name="Rich Reba" userId="8245d172-5b81-40f1-a13b-b71f02cd6700" providerId="ADAL" clId="{4AB8F1AF-C3AC-A441-B0A6-C34DB2CDE3D6}" dt="2024-10-24T18:25:07.175" v="1924" actId="20577"/>
-          <ac:spMkLst>
-            <pc:docMk/>
-            <pc:sldMk cId="2639682451" sldId="275"/>
-            <ac:spMk id="96" creationId="{00000000-0000-0000-0000-000000000000}"/>
-          </ac:spMkLst>
-        </pc:spChg>
-        <pc:graphicFrameChg chg="add del mod">
-          <ac:chgData name="Rich Reba" userId="8245d172-5b81-40f1-a13b-b71f02cd6700" providerId="ADAL" clId="{4AB8F1AF-C3AC-A441-B0A6-C34DB2CDE3D6}" dt="2024-10-24T18:24:58.385" v="1904" actId="478"/>
-          <ac:graphicFrameMkLst>
-            <pc:docMk/>
-            <pc:sldMk cId="2639682451" sldId="275"/>
-            <ac:graphicFrameMk id="5" creationId="{28903738-00FE-5BBD-8785-5578B77082FA}"/>
-          </ac:graphicFrameMkLst>
-        </pc:graphicFrameChg>
-        <pc:graphicFrameChg chg="del">
-          <ac:chgData name="Rich Reba" userId="8245d172-5b81-40f1-a13b-b71f02cd6700" providerId="ADAL" clId="{4AB8F1AF-C3AC-A441-B0A6-C34DB2CDE3D6}" dt="2024-10-22T01:11:56.533" v="6" actId="478"/>
-          <ac:graphicFrameMkLst>
-            <pc:docMk/>
-            <pc:sldMk cId="2639682451" sldId="275"/>
-            <ac:graphicFrameMk id="5" creationId="{4B70F3A5-8062-29A2-30D0-2783CB3DFCCA}"/>
-          </ac:graphicFrameMkLst>
-        </pc:graphicFrameChg>
-        <pc:graphicFrameChg chg="add del mod">
-          <ac:chgData name="Rich Reba" userId="8245d172-5b81-40f1-a13b-b71f02cd6700" providerId="ADAL" clId="{4AB8F1AF-C3AC-A441-B0A6-C34DB2CDE3D6}" dt="2024-10-24T18:16:51.841" v="1870" actId="478"/>
-          <ac:graphicFrameMkLst>
-            <pc:docMk/>
-            <pc:sldMk cId="2639682451" sldId="275"/>
-            <ac:graphicFrameMk id="7" creationId="{0695BD01-8951-402D-C803-2223760DD3D6}"/>
-          </ac:graphicFrameMkLst>
-        </pc:graphicFrameChg>
-        <pc:graphicFrameChg chg="add mod">
-          <ac:chgData name="Rich Reba" userId="8245d172-5b81-40f1-a13b-b71f02cd6700" providerId="ADAL" clId="{4AB8F1AF-C3AC-A441-B0A6-C34DB2CDE3D6}" dt="2024-10-24T18:24:58.930" v="1905"/>
-          <ac:graphicFrameMkLst>
-            <pc:docMk/>
-            <pc:sldMk cId="2639682451" sldId="275"/>
-            <ac:graphicFrameMk id="8" creationId="{EAC54515-146B-F050-4501-5918908F45C7}"/>
-          </ac:graphicFrameMkLst>
-        </pc:graphicFrameChg>
-      </pc:sldChg>
-      <pc:sldChg chg="modSp mod">
-        <pc:chgData name="Rich Reba" userId="8245d172-5b81-40f1-a13b-b71f02cd6700" providerId="ADAL" clId="{4AB8F1AF-C3AC-A441-B0A6-C34DB2CDE3D6}" dt="2024-11-01T19:15:27.113" v="2234" actId="14734"/>
-        <pc:sldMkLst>
-          <pc:docMk/>
-          <pc:sldMk cId="3191730488" sldId="276"/>
-        </pc:sldMkLst>
-        <pc:spChg chg="mod">
-          <ac:chgData name="Rich Reba" userId="8245d172-5b81-40f1-a13b-b71f02cd6700" providerId="ADAL" clId="{4AB8F1AF-C3AC-A441-B0A6-C34DB2CDE3D6}" dt="2024-10-23T20:52:34.260" v="345" actId="20577"/>
-          <ac:spMkLst>
-            <pc:docMk/>
-            <pc:sldMk cId="3191730488" sldId="276"/>
-            <ac:spMk id="96" creationId="{00000000-0000-0000-0000-000000000000}"/>
-          </ac:spMkLst>
-        </pc:spChg>
-        <pc:graphicFrameChg chg="modGraphic">
-          <ac:chgData name="Rich Reba" userId="8245d172-5b81-40f1-a13b-b71f02cd6700" providerId="ADAL" clId="{4AB8F1AF-C3AC-A441-B0A6-C34DB2CDE3D6}" dt="2024-11-01T19:15:27.113" v="2234" actId="14734"/>
-          <ac:graphicFrameMkLst>
-            <pc:docMk/>
-            <pc:sldMk cId="3191730488" sldId="276"/>
-            <ac:graphicFrameMk id="5" creationId="{4B70F3A5-8062-29A2-30D0-2783CB3DFCCA}"/>
-          </ac:graphicFrameMkLst>
-        </pc:graphicFrameChg>
-      </pc:sldChg>
-      <pc:sldChg chg="addSp delSp modSp mod">
-        <pc:chgData name="Rich Reba" userId="8245d172-5b81-40f1-a13b-b71f02cd6700" providerId="ADAL" clId="{4AB8F1AF-C3AC-A441-B0A6-C34DB2CDE3D6}" dt="2024-10-24T17:37:33.558" v="913"/>
-        <pc:sldMkLst>
-          <pc:docMk/>
-          <pc:sldMk cId="368434212" sldId="277"/>
-        </pc:sldMkLst>
-        <pc:graphicFrameChg chg="del modGraphic">
-          <ac:chgData name="Rich Reba" userId="8245d172-5b81-40f1-a13b-b71f02cd6700" providerId="ADAL" clId="{4AB8F1AF-C3AC-A441-B0A6-C34DB2CDE3D6}" dt="2024-10-24T17:37:32.529" v="912" actId="478"/>
-          <ac:graphicFrameMkLst>
-            <pc:docMk/>
-            <pc:sldMk cId="368434212" sldId="277"/>
-            <ac:graphicFrameMk id="2" creationId="{30929ABE-0A38-27D1-4713-A9783350A181}"/>
-          </ac:graphicFrameMkLst>
-        </pc:graphicFrameChg>
-        <pc:graphicFrameChg chg="add mod">
-          <ac:chgData name="Rich Reba" userId="8245d172-5b81-40f1-a13b-b71f02cd6700" providerId="ADAL" clId="{4AB8F1AF-C3AC-A441-B0A6-C34DB2CDE3D6}" dt="2024-10-24T17:37:33.558" v="913"/>
-          <ac:graphicFrameMkLst>
-            <pc:docMk/>
-            <pc:sldMk cId="368434212" sldId="277"/>
-            <ac:graphicFrameMk id="4" creationId="{DF0CCA37-1217-B7D3-8320-72D1D9B53C50}"/>
-          </ac:graphicFrameMkLst>
-        </pc:graphicFrameChg>
-      </pc:sldChg>
-      <pc:sldChg chg="modSp add mod">
-        <pc:chgData name="Rich Reba" userId="8245d172-5b81-40f1-a13b-b71f02cd6700" providerId="ADAL" clId="{4AB8F1AF-C3AC-A441-B0A6-C34DB2CDE3D6}" dt="2024-10-24T18:24:42.312" v="1903"/>
-        <pc:sldMkLst>
-          <pc:docMk/>
-          <pc:sldMk cId="3960435043" sldId="281"/>
-        </pc:sldMkLst>
-        <pc:spChg chg="mod">
-          <ac:chgData name="Rich Reba" userId="8245d172-5b81-40f1-a13b-b71f02cd6700" providerId="ADAL" clId="{4AB8F1AF-C3AC-A441-B0A6-C34DB2CDE3D6}" dt="2024-10-24T18:14:50.626" v="1765" actId="20577"/>
-          <ac:spMkLst>
-            <pc:docMk/>
-            <pc:sldMk cId="3960435043" sldId="281"/>
-            <ac:spMk id="96" creationId="{00000000-0000-0000-0000-000000000000}"/>
-          </ac:spMkLst>
-        </pc:spChg>
-        <pc:graphicFrameChg chg="mod modGraphic">
-          <ac:chgData name="Rich Reba" userId="8245d172-5b81-40f1-a13b-b71f02cd6700" providerId="ADAL" clId="{4AB8F1AF-C3AC-A441-B0A6-C34DB2CDE3D6}" dt="2024-10-24T18:24:42.312" v="1903"/>
-          <ac:graphicFrameMkLst>
-            <pc:docMk/>
-            <pc:sldMk cId="3960435043" sldId="281"/>
-            <ac:graphicFrameMk id="5" creationId="{4B70F3A5-8062-29A2-30D0-2783CB3DFCCA}"/>
-          </ac:graphicFrameMkLst>
-        </pc:graphicFrameChg>
-      </pc:sldChg>
-      <pc:sldChg chg="modSp add del mod">
-        <pc:chgData name="Rich Reba" userId="8245d172-5b81-40f1-a13b-b71f02cd6700" providerId="ADAL" clId="{4AB8F1AF-C3AC-A441-B0A6-C34DB2CDE3D6}" dt="2024-10-24T17:37:44.353" v="914" actId="2696"/>
-        <pc:sldMkLst>
-          <pc:docMk/>
-          <pc:sldMk cId="4159369405" sldId="281"/>
-        </pc:sldMkLst>
-        <pc:graphicFrameChg chg="mod modGraphic">
-          <ac:chgData name="Rich Reba" userId="8245d172-5b81-40f1-a13b-b71f02cd6700" providerId="ADAL" clId="{4AB8F1AF-C3AC-A441-B0A6-C34DB2CDE3D6}" dt="2024-10-22T01:11:43.823" v="4"/>
-          <ac:graphicFrameMkLst>
-            <pc:docMk/>
-            <pc:sldMk cId="4159369405" sldId="281"/>
-            <ac:graphicFrameMk id="5" creationId="{4B70F3A5-8062-29A2-30D0-2783CB3DFCCA}"/>
-          </ac:graphicFrameMkLst>
-        </pc:graphicFrameChg>
-      </pc:sldChg>
-      <pc:sldChg chg="add del">
-        <pc:chgData name="Rich Reba" userId="8245d172-5b81-40f1-a13b-b71f02cd6700" providerId="ADAL" clId="{4AB8F1AF-C3AC-A441-B0A6-C34DB2CDE3D6}" dt="2024-10-24T17:50:32.509" v="949" actId="2696"/>
-        <pc:sldMkLst>
-          <pc:docMk/>
-          <pc:sldMk cId="1398130709" sldId="282"/>
-        </pc:sldMkLst>
-      </pc:sldChg>
-    </pc:docChg>
-  </pc:docChgLst>
-  <pc:docChgLst>
-    <pc:chgData name="Rich Reba" userId="8245d172-5b81-40f1-a13b-b71f02cd6700" providerId="ADAL" clId="{1F8583C6-4D3D-FC4B-B89E-87F4AA8D44B0}"/>
-    <pc:docChg chg="undo custSel addSld delSld modSld modMainMaster">
-      <pc:chgData name="Rich Reba" userId="8245d172-5b81-40f1-a13b-b71f02cd6700" providerId="ADAL" clId="{1F8583C6-4D3D-FC4B-B89E-87F4AA8D44B0}" dt="2024-04-17T12:43:51.355" v="3539"/>
-      <pc:docMkLst>
-        <pc:docMk/>
-      </pc:docMkLst>
-      <pc:sldChg chg="addSp modSp mod">
-        <pc:chgData name="Rich Reba" userId="8245d172-5b81-40f1-a13b-b71f02cd6700" providerId="ADAL" clId="{1F8583C6-4D3D-FC4B-B89E-87F4AA8D44B0}" dt="2024-04-17T12:43:01.136" v="3512"/>
-        <pc:sldMkLst>
-          <pc:docMk/>
-          <pc:sldMk cId="0" sldId="256"/>
-        </pc:sldMkLst>
-        <pc:spChg chg="add mod">
-          <ac:chgData name="Rich Reba" userId="8245d172-5b81-40f1-a13b-b71f02cd6700" providerId="ADAL" clId="{1F8583C6-4D3D-FC4B-B89E-87F4AA8D44B0}" dt="2024-04-17T12:43:01.136" v="3512"/>
-          <ac:spMkLst>
-            <pc:docMk/>
-            <pc:sldMk cId="0" sldId="256"/>
-            <ac:spMk id="2" creationId="{B78BEAA4-CC48-1EF1-1035-C48CDEB46C11}"/>
-          </ac:spMkLst>
-        </pc:spChg>
-        <pc:spChg chg="mod">
-          <ac:chgData name="Rich Reba" userId="8245d172-5b81-40f1-a13b-b71f02cd6700" providerId="ADAL" clId="{1F8583C6-4D3D-FC4B-B89E-87F4AA8D44B0}" dt="2024-04-11T22:03:33.343" v="73" actId="14100"/>
-          <ac:spMkLst>
-            <pc:docMk/>
-            <pc:sldMk cId="0" sldId="256"/>
-            <ac:spMk id="90" creationId="{00000000-0000-0000-0000-000000000000}"/>
-          </ac:spMkLst>
-        </pc:spChg>
-      </pc:sldChg>
-      <pc:sldChg chg="del">
-        <pc:chgData name="Rich Reba" userId="8245d172-5b81-40f1-a13b-b71f02cd6700" providerId="ADAL" clId="{1F8583C6-4D3D-FC4B-B89E-87F4AA8D44B0}" dt="2024-04-11T22:04:52.048" v="74" actId="2696"/>
-        <pc:sldMkLst>
-          <pc:docMk/>
-          <pc:sldMk cId="0" sldId="257"/>
-        </pc:sldMkLst>
-      </pc:sldChg>
-      <pc:sldChg chg="add del">
-        <pc:chgData name="Rich Reba" userId="8245d172-5b81-40f1-a13b-b71f02cd6700" providerId="ADAL" clId="{1F8583C6-4D3D-FC4B-B89E-87F4AA8D44B0}" dt="2024-04-11T22:04:55.605" v="85" actId="2696"/>
-        <pc:sldMkLst>
-          <pc:docMk/>
-          <pc:sldMk cId="3978776499" sldId="258"/>
-        </pc:sldMkLst>
-      </pc:sldChg>
-      <pc:sldChg chg="add del">
-        <pc:chgData name="Rich Reba" userId="8245d172-5b81-40f1-a13b-b71f02cd6700" providerId="ADAL" clId="{1F8583C6-4D3D-FC4B-B89E-87F4AA8D44B0}" dt="2024-04-11T22:13:46.757" v="957" actId="2696"/>
-        <pc:sldMkLst>
-          <pc:docMk/>
-          <pc:sldMk cId="0" sldId="261"/>
-        </pc:sldMkLst>
-      </pc:sldChg>
-      <pc:sldChg chg="add del">
-        <pc:chgData name="Rich Reba" userId="8245d172-5b81-40f1-a13b-b71f02cd6700" providerId="ADAL" clId="{1F8583C6-4D3D-FC4B-B89E-87F4AA8D44B0}" dt="2024-04-11T22:06:31.697" v="109" actId="2696"/>
-        <pc:sldMkLst>
-          <pc:docMk/>
-          <pc:sldMk cId="1692280443" sldId="262"/>
-        </pc:sldMkLst>
-      </pc:sldChg>
-      <pc:sldChg chg="add del">
-        <pc:chgData name="Rich Reba" userId="8245d172-5b81-40f1-a13b-b71f02cd6700" providerId="ADAL" clId="{1F8583C6-4D3D-FC4B-B89E-87F4AA8D44B0}" dt="2024-04-11T22:06:31.716" v="110" actId="2696"/>
-        <pc:sldMkLst>
-          <pc:docMk/>
-          <pc:sldMk cId="2471547366" sldId="263"/>
-        </pc:sldMkLst>
-      </pc:sldChg>
-      <pc:sldChg chg="addSp modSp add del mod">
-        <pc:chgData name="Rich Reba" userId="8245d172-5b81-40f1-a13b-b71f02cd6700" providerId="ADAL" clId="{1F8583C6-4D3D-FC4B-B89E-87F4AA8D44B0}" dt="2024-04-17T12:43:23.521" v="3526" actId="1035"/>
-        <pc:sldMkLst>
-          <pc:docMk/>
-          <pc:sldMk cId="1272635936" sldId="264"/>
-        </pc:sldMkLst>
-        <pc:spChg chg="add mod">
-          <ac:chgData name="Rich Reba" userId="8245d172-5b81-40f1-a13b-b71f02cd6700" providerId="ADAL" clId="{1F8583C6-4D3D-FC4B-B89E-87F4AA8D44B0}" dt="2024-04-17T12:43:05.406" v="3514"/>
-          <ac:spMkLst>
-            <pc:docMk/>
-            <pc:sldMk cId="1272635936" sldId="264"/>
-            <ac:spMk id="6" creationId="{F57F7845-FD8A-DCA4-39DB-1B7D9CF0BA2A}"/>
-          </ac:spMkLst>
-        </pc:spChg>
-        <pc:spChg chg="mod">
-          <ac:chgData name="Rich Reba" userId="8245d172-5b81-40f1-a13b-b71f02cd6700" providerId="ADAL" clId="{1F8583C6-4D3D-FC4B-B89E-87F4AA8D44B0}" dt="2024-04-11T22:06:35.024" v="118" actId="20577"/>
-          <ac:spMkLst>
-            <pc:docMk/>
-            <pc:sldMk cId="1272635936" sldId="264"/>
-            <ac:spMk id="96" creationId="{00000000-0000-0000-0000-000000000000}"/>
-          </ac:spMkLst>
-        </pc:spChg>
-        <pc:graphicFrameChg chg="mod modGraphic">
-          <ac:chgData name="Rich Reba" userId="8245d172-5b81-40f1-a13b-b71f02cd6700" providerId="ADAL" clId="{1F8583C6-4D3D-FC4B-B89E-87F4AA8D44B0}" dt="2024-04-17T12:43:23.521" v="3526" actId="1035"/>
-          <ac:graphicFrameMkLst>
-            <pc:docMk/>
-            <pc:sldMk cId="1272635936" sldId="264"/>
-            <ac:graphicFrameMk id="5" creationId="{4B70F3A5-8062-29A2-30D0-2783CB3DFCCA}"/>
-          </ac:graphicFrameMkLst>
-        </pc:graphicFrameChg>
-      </pc:sldChg>
-      <pc:sldChg chg="del">
-        <pc:chgData name="Rich Reba" userId="8245d172-5b81-40f1-a13b-b71f02cd6700" providerId="ADAL" clId="{1F8583C6-4D3D-FC4B-B89E-87F4AA8D44B0}" dt="2024-04-11T22:04:52.171" v="82" actId="2696"/>
-        <pc:sldMkLst>
-          <pc:docMk/>
-          <pc:sldMk cId="1338552404" sldId="264"/>
-        </pc:sldMkLst>
-      </pc:sldChg>
-      <pc:sldChg chg="modSp new del mod">
-        <pc:chgData name="Rich Reba" userId="8245d172-5b81-40f1-a13b-b71f02cd6700" providerId="ADAL" clId="{1F8583C6-4D3D-FC4B-B89E-87F4AA8D44B0}" dt="2024-04-12T03:35:44.181" v="1878" actId="2696"/>
-        <pc:sldMkLst>
-          <pc:docMk/>
-          <pc:sldMk cId="4108533982" sldId="265"/>
-        </pc:sldMkLst>
-        <pc:spChg chg="mod">
-          <ac:chgData name="Rich Reba" userId="8245d172-5b81-40f1-a13b-b71f02cd6700" providerId="ADAL" clId="{1F8583C6-4D3D-FC4B-B89E-87F4AA8D44B0}" dt="2024-04-11T22:24:04.424" v="1137" actId="20577"/>
-          <ac:spMkLst>
-            <pc:docMk/>
-            <pc:sldMk cId="4108533982" sldId="265"/>
-            <ac:spMk id="2" creationId="{B85FA768-8259-9E0E-4319-23E47B82E0D1}"/>
-          </ac:spMkLst>
-        </pc:spChg>
-        <pc:spChg chg="mod">
-          <ac:chgData name="Rich Reba" userId="8245d172-5b81-40f1-a13b-b71f02cd6700" providerId="ADAL" clId="{1F8583C6-4D3D-FC4B-B89E-87F4AA8D44B0}" dt="2024-04-11T22:24:07.935" v="1152" actId="20577"/>
-          <ac:spMkLst>
-            <pc:docMk/>
-            <pc:sldMk cId="4108533982" sldId="265"/>
-            <ac:spMk id="3" creationId="{C3E43DF4-B545-3BE4-7CC1-EBD57B49AF83}"/>
-          </ac:spMkLst>
-        </pc:spChg>
-      </pc:sldChg>
-      <pc:sldChg chg="del">
-        <pc:chgData name="Rich Reba" userId="8245d172-5b81-40f1-a13b-b71f02cd6700" providerId="ADAL" clId="{1F8583C6-4D3D-FC4B-B89E-87F4AA8D44B0}" dt="2024-04-11T22:04:52.126" v="80" actId="2696"/>
-        <pc:sldMkLst>
-          <pc:docMk/>
-          <pc:sldMk cId="3116950362" sldId="266"/>
-        </pc:sldMkLst>
-      </pc:sldChg>
-      <pc:sldChg chg="addSp modSp add del mod">
-        <pc:chgData name="Rich Reba" userId="8245d172-5b81-40f1-a13b-b71f02cd6700" providerId="ADAL" clId="{1F8583C6-4D3D-FC4B-B89E-87F4AA8D44B0}" dt="2024-04-17T12:43:26.787" v="3527"/>
-        <pc:sldMkLst>
-          <pc:docMk/>
-          <pc:sldMk cId="4188122143" sldId="266"/>
-        </pc:sldMkLst>
-        <pc:spChg chg="add mod">
-          <ac:chgData name="Rich Reba" userId="8245d172-5b81-40f1-a13b-b71f02cd6700" providerId="ADAL" clId="{1F8583C6-4D3D-FC4B-B89E-87F4AA8D44B0}" dt="2024-04-17T12:43:26.787" v="3527"/>
-          <ac:spMkLst>
-            <pc:docMk/>
-            <pc:sldMk cId="4188122143" sldId="266"/>
-            <ac:spMk id="5" creationId="{C5748C3E-8A70-958C-B8E4-332FC5861BB3}"/>
-          </ac:spMkLst>
-        </pc:spChg>
-        <pc:spChg chg="mod">
-          <ac:chgData name="Rich Reba" userId="8245d172-5b81-40f1-a13b-b71f02cd6700" providerId="ADAL" clId="{1F8583C6-4D3D-FC4B-B89E-87F4AA8D44B0}" dt="2024-04-11T22:13:06.741" v="916" actId="20577"/>
-          <ac:spMkLst>
-            <pc:docMk/>
-            <pc:sldMk cId="4188122143" sldId="266"/>
-            <ac:spMk id="96" creationId="{00000000-0000-0000-0000-000000000000}"/>
-          </ac:spMkLst>
-        </pc:spChg>
-        <pc:graphicFrameChg chg="modGraphic">
-          <ac:chgData name="Rich Reba" userId="8245d172-5b81-40f1-a13b-b71f02cd6700" providerId="ADAL" clId="{1F8583C6-4D3D-FC4B-B89E-87F4AA8D44B0}" dt="2024-04-11T22:13:33.840" v="955" actId="20577"/>
-          <ac:graphicFrameMkLst>
-            <pc:docMk/>
-            <pc:sldMk cId="4188122143" sldId="266"/>
-            <ac:graphicFrameMk id="5" creationId="{4B70F3A5-8062-29A2-30D0-2783CB3DFCCA}"/>
-          </ac:graphicFrameMkLst>
-        </pc:graphicFrameChg>
-      </pc:sldChg>
-      <pc:sldChg chg="modSp add del mod">
-        <pc:chgData name="Rich Reba" userId="8245d172-5b81-40f1-a13b-b71f02cd6700" providerId="ADAL" clId="{1F8583C6-4D3D-FC4B-B89E-87F4AA8D44B0}" dt="2024-04-12T03:35:44.192" v="1883" actId="2696"/>
-        <pc:sldMkLst>
-          <pc:docMk/>
-          <pc:sldMk cId="252206901" sldId="267"/>
-        </pc:sldMkLst>
-        <pc:spChg chg="mod">
-          <ac:chgData name="Rich Reba" userId="8245d172-5b81-40f1-a13b-b71f02cd6700" providerId="ADAL" clId="{1F8583C6-4D3D-FC4B-B89E-87F4AA8D44B0}" dt="2024-04-11T22:23:45.816" v="1104" actId="20577"/>
-          <ac:spMkLst>
-            <pc:docMk/>
-            <pc:sldMk cId="252206901" sldId="267"/>
-            <ac:spMk id="2" creationId="{B85FA768-8259-9E0E-4319-23E47B82E0D1}"/>
-          </ac:spMkLst>
-        </pc:spChg>
-        <pc:spChg chg="mod">
-          <ac:chgData name="Rich Reba" userId="8245d172-5b81-40f1-a13b-b71f02cd6700" providerId="ADAL" clId="{1F8583C6-4D3D-FC4B-B89E-87F4AA8D44B0}" dt="2024-04-11T22:23:49.256" v="1118" actId="20577"/>
-          <ac:spMkLst>
-            <pc:docMk/>
-            <pc:sldMk cId="252206901" sldId="267"/>
-            <ac:spMk id="3" creationId="{C3E43DF4-B545-3BE4-7CC1-EBD57B49AF83}"/>
-          </ac:spMkLst>
-        </pc:spChg>
-      </pc:sldChg>
-      <pc:sldChg chg="del">
-        <pc:chgData name="Rich Reba" userId="8245d172-5b81-40f1-a13b-b71f02cd6700" providerId="ADAL" clId="{1F8583C6-4D3D-FC4B-B89E-87F4AA8D44B0}" dt="2024-04-11T22:04:52.052" v="76" actId="2696"/>
-        <pc:sldMkLst>
-          <pc:docMk/>
-          <pc:sldMk cId="3415586087" sldId="267"/>
-        </pc:sldMkLst>
-      </pc:sldChg>
-      <pc:sldChg chg="addSp delSp modSp add del mod">
-        <pc:chgData name="Rich Reba" userId="8245d172-5b81-40f1-a13b-b71f02cd6700" providerId="ADAL" clId="{1F8583C6-4D3D-FC4B-B89E-87F4AA8D44B0}" dt="2024-04-17T12:43:37.115" v="3532"/>
-        <pc:sldMkLst>
-          <pc:docMk/>
-          <pc:sldMk cId="1243007551" sldId="268"/>
-        </pc:sldMkLst>
-        <pc:spChg chg="add mod">
-          <ac:chgData name="Rich Reba" userId="8245d172-5b81-40f1-a13b-b71f02cd6700" providerId="ADAL" clId="{1F8583C6-4D3D-FC4B-B89E-87F4AA8D44B0}" dt="2024-04-17T12:43:37.115" v="3532"/>
-          <ac:spMkLst>
-            <pc:docMk/>
-            <pc:sldMk cId="1243007551" sldId="268"/>
-            <ac:spMk id="6" creationId="{FC3986F6-425A-0514-DE8E-DE31978EAAD1}"/>
-          </ac:spMkLst>
-        </pc:spChg>
-        <pc:spChg chg="mod">
-          <ac:chgData name="Rich Reba" userId="8245d172-5b81-40f1-a13b-b71f02cd6700" providerId="ADAL" clId="{1F8583C6-4D3D-FC4B-B89E-87F4AA8D44B0}" dt="2024-04-11T22:22:49.804" v="1084" actId="20577"/>
-          <ac:spMkLst>
-            <pc:docMk/>
-            <pc:sldMk cId="1243007551" sldId="268"/>
-            <ac:spMk id="96" creationId="{00000000-0000-0000-0000-000000000000}"/>
-          </ac:spMkLst>
-        </pc:spChg>
-        <pc:graphicFrameChg chg="add mod modGraphic">
-          <ac:chgData name="Rich Reba" userId="8245d172-5b81-40f1-a13b-b71f02cd6700" providerId="ADAL" clId="{1F8583C6-4D3D-FC4B-B89E-87F4AA8D44B0}" dt="2024-04-11T22:17:30.299" v="1008" actId="403"/>
-          <ac:graphicFrameMkLst>
-            <pc:docMk/>
-            <pc:sldMk cId="1243007551" sldId="268"/>
-            <ac:graphicFrameMk id="2" creationId="{849548E0-A616-4177-21C8-C63119ADCD53}"/>
-          </ac:graphicFrameMkLst>
-        </pc:graphicFrameChg>
-        <pc:graphicFrameChg chg="del">
-          <ac:chgData name="Rich Reba" userId="8245d172-5b81-40f1-a13b-b71f02cd6700" providerId="ADAL" clId="{1F8583C6-4D3D-FC4B-B89E-87F4AA8D44B0}" dt="2024-04-11T22:16:21.214" v="995" actId="478"/>
-          <ac:graphicFrameMkLst>
-            <pc:docMk/>
-            <pc:sldMk cId="1243007551" sldId="268"/>
-            <ac:graphicFrameMk id="5" creationId="{4B70F3A5-8062-29A2-30D0-2783CB3DFCCA}"/>
-          </ac:graphicFrameMkLst>
-        </pc:graphicFrameChg>
-      </pc:sldChg>
-      <pc:sldChg chg="del">
-        <pc:chgData name="Rich Reba" userId="8245d172-5b81-40f1-a13b-b71f02cd6700" providerId="ADAL" clId="{1F8583C6-4D3D-FC4B-B89E-87F4AA8D44B0}" dt="2024-04-11T22:04:52.162" v="81" actId="2696"/>
-        <pc:sldMkLst>
-          <pc:docMk/>
-          <pc:sldMk cId="2415387204" sldId="268"/>
-        </pc:sldMkLst>
-      </pc:sldChg>
-      <pc:sldChg chg="addSp modSp add del mod">
-        <pc:chgData name="Rich Reba" userId="8245d172-5b81-40f1-a13b-b71f02cd6700" providerId="ADAL" clId="{1F8583C6-4D3D-FC4B-B89E-87F4AA8D44B0}" dt="2024-04-17T12:43:38.667" v="3533"/>
-        <pc:sldMkLst>
-          <pc:docMk/>
-          <pc:sldMk cId="450257364" sldId="269"/>
-        </pc:sldMkLst>
-        <pc:spChg chg="add mod">
-          <ac:chgData name="Rich Reba" userId="8245d172-5b81-40f1-a13b-b71f02cd6700" providerId="ADAL" clId="{1F8583C6-4D3D-FC4B-B89E-87F4AA8D44B0}" dt="2024-04-17T12:43:38.667" v="3533"/>
-          <ac:spMkLst>
-            <pc:docMk/>
-            <pc:sldMk cId="450257364" sldId="269"/>
-            <ac:spMk id="7" creationId="{31CA48FC-F211-DAFD-902B-5D682C6B56DD}"/>
-          </ac:spMkLst>
-        </pc:spChg>
-        <pc:spChg chg="mod">
-          <ac:chgData name="Rich Reba" userId="8245d172-5b81-40f1-a13b-b71f02cd6700" providerId="ADAL" clId="{1F8583C6-4D3D-FC4B-B89E-87F4AA8D44B0}" dt="2024-04-11T22:22:47.030" v="1082" actId="20577"/>
-          <ac:spMkLst>
-            <pc:docMk/>
-            <pc:sldMk cId="450257364" sldId="269"/>
-            <ac:spMk id="96" creationId="{00000000-0000-0000-0000-000000000000}"/>
-          </ac:spMkLst>
-        </pc:spChg>
-        <pc:graphicFrameChg chg="mod modGraphic">
-          <ac:chgData name="Rich Reba" userId="8245d172-5b81-40f1-a13b-b71f02cd6700" providerId="ADAL" clId="{1F8583C6-4D3D-FC4B-B89E-87F4AA8D44B0}" dt="2024-04-11T22:17:54.472" v="1016" actId="403"/>
-          <ac:graphicFrameMkLst>
-            <pc:docMk/>
-            <pc:sldMk cId="450257364" sldId="269"/>
-            <ac:graphicFrameMk id="2" creationId="{849548E0-A616-4177-21C8-C63119ADCD53}"/>
-          </ac:graphicFrameMkLst>
-        </pc:graphicFrameChg>
-      </pc:sldChg>
-      <pc:sldChg chg="addSp delSp modSp add del mod">
-        <pc:chgData name="Rich Reba" userId="8245d172-5b81-40f1-a13b-b71f02cd6700" providerId="ADAL" clId="{1F8583C6-4D3D-FC4B-B89E-87F4AA8D44B0}" dt="2024-04-17T12:43:44.942" v="3535" actId="1076"/>
-        <pc:sldMkLst>
-          <pc:docMk/>
-          <pc:sldMk cId="4255637138" sldId="270"/>
-        </pc:sldMkLst>
-        <pc:spChg chg="add mod">
-          <ac:chgData name="Rich Reba" userId="8245d172-5b81-40f1-a13b-b71f02cd6700" providerId="ADAL" clId="{1F8583C6-4D3D-FC4B-B89E-87F4AA8D44B0}" dt="2024-04-17T12:43:40.314" v="3534"/>
-          <ac:spMkLst>
-            <pc:docMk/>
-            <pc:sldMk cId="4255637138" sldId="270"/>
-            <ac:spMk id="7" creationId="{7FE450E7-5500-1557-7587-B39724023C17}"/>
-          </ac:spMkLst>
-        </pc:spChg>
-        <pc:spChg chg="mod">
-          <ac:chgData name="Rich Reba" userId="8245d172-5b81-40f1-a13b-b71f02cd6700" providerId="ADAL" clId="{1F8583C6-4D3D-FC4B-B89E-87F4AA8D44B0}" dt="2024-04-11T22:22:44.211" v="1080" actId="20577"/>
-          <ac:spMkLst>
-            <pc:docMk/>
-            <pc:sldMk cId="4255637138" sldId="270"/>
-            <ac:spMk id="96" creationId="{00000000-0000-0000-0000-000000000000}"/>
-          </ac:spMkLst>
-        </pc:spChg>
-        <pc:graphicFrameChg chg="del">
-          <ac:chgData name="Rich Reba" userId="8245d172-5b81-40f1-a13b-b71f02cd6700" providerId="ADAL" clId="{1F8583C6-4D3D-FC4B-B89E-87F4AA8D44B0}" dt="2024-04-11T22:19:04.946" v="1022" actId="478"/>
-          <ac:graphicFrameMkLst>
-            <pc:docMk/>
-            <pc:sldMk cId="4255637138" sldId="270"/>
-            <ac:graphicFrameMk id="2" creationId="{849548E0-A616-4177-21C8-C63119ADCD53}"/>
-          </ac:graphicFrameMkLst>
-        </pc:graphicFrameChg>
-        <pc:graphicFrameChg chg="add mod modGraphic">
-          <ac:chgData name="Rich Reba" userId="8245d172-5b81-40f1-a13b-b71f02cd6700" providerId="ADAL" clId="{1F8583C6-4D3D-FC4B-B89E-87F4AA8D44B0}" dt="2024-04-17T12:43:44.942" v="3535" actId="1076"/>
-          <ac:graphicFrameMkLst>
-            <pc:docMk/>
-            <pc:sldMk cId="4255637138" sldId="270"/>
-            <ac:graphicFrameMk id="3" creationId="{14B79CD4-17D9-A460-45EE-070B6CD3DAFF}"/>
-          </ac:graphicFrameMkLst>
-        </pc:graphicFrameChg>
-      </pc:sldChg>
-      <pc:sldChg chg="addSp delSp modSp add del mod">
-        <pc:chgData name="Rich Reba" userId="8245d172-5b81-40f1-a13b-b71f02cd6700" providerId="ADAL" clId="{1F8583C6-4D3D-FC4B-B89E-87F4AA8D44B0}" dt="2024-04-17T12:43:46.546" v="3536"/>
-        <pc:sldMkLst>
-          <pc:docMk/>
-          <pc:sldMk cId="67448461" sldId="271"/>
-        </pc:sldMkLst>
-        <pc:spChg chg="add mod">
-          <ac:chgData name="Rich Reba" userId="8245d172-5b81-40f1-a13b-b71f02cd6700" providerId="ADAL" clId="{1F8583C6-4D3D-FC4B-B89E-87F4AA8D44B0}" dt="2024-04-17T12:43:46.546" v="3536"/>
-          <ac:spMkLst>
-            <pc:docMk/>
-            <pc:sldMk cId="67448461" sldId="271"/>
-            <ac:spMk id="7" creationId="{E84B6E51-E573-5BC3-2F49-2CB36E1EC08D}"/>
-          </ac:spMkLst>
-        </pc:spChg>
-        <pc:spChg chg="mod">
-          <ac:chgData name="Rich Reba" userId="8245d172-5b81-40f1-a13b-b71f02cd6700" providerId="ADAL" clId="{1F8583C6-4D3D-FC4B-B89E-87F4AA8D44B0}" dt="2024-04-11T22:22:41.390" v="1078" actId="20577"/>
-          <ac:spMkLst>
-            <pc:docMk/>
-            <pc:sldMk cId="67448461" sldId="271"/>
-            <ac:spMk id="96" creationId="{00000000-0000-0000-0000-000000000000}"/>
-          </ac:spMkLst>
-        </pc:spChg>
-        <pc:graphicFrameChg chg="add mod modGraphic">
-          <ac:chgData name="Rich Reba" userId="8245d172-5b81-40f1-a13b-b71f02cd6700" providerId="ADAL" clId="{1F8583C6-4D3D-FC4B-B89E-87F4AA8D44B0}" dt="2024-04-11T22:21:23.006" v="1064" actId="404"/>
-          <ac:graphicFrameMkLst>
-            <pc:docMk/>
-            <pc:sldMk cId="67448461" sldId="271"/>
-            <ac:graphicFrameMk id="2" creationId="{59DCEAC8-DB72-C8D9-0DB4-F8D83D801ADB}"/>
-          </ac:graphicFrameMkLst>
-        </pc:graphicFrameChg>
-        <pc:graphicFrameChg chg="del">
-          <ac:chgData name="Rich Reba" userId="8245d172-5b81-40f1-a13b-b71f02cd6700" providerId="ADAL" clId="{1F8583C6-4D3D-FC4B-B89E-87F4AA8D44B0}" dt="2024-04-11T22:20:31.926" v="1038" actId="478"/>
-          <ac:graphicFrameMkLst>
-            <pc:docMk/>
-            <pc:sldMk cId="67448461" sldId="271"/>
-            <ac:graphicFrameMk id="3" creationId="{14B79CD4-17D9-A460-45EE-070B6CD3DAFF}"/>
-          </ac:graphicFrameMkLst>
-        </pc:graphicFrameChg>
-      </pc:sldChg>
-      <pc:sldChg chg="addSp delSp modSp add del mod">
-        <pc:chgData name="Rich Reba" userId="8245d172-5b81-40f1-a13b-b71f02cd6700" providerId="ADAL" clId="{1F8583C6-4D3D-FC4B-B89E-87F4AA8D44B0}" dt="2024-04-17T12:43:48.128" v="3537"/>
-        <pc:sldMkLst>
-          <pc:docMk/>
-          <pc:sldMk cId="3088802820" sldId="272"/>
-        </pc:sldMkLst>
-        <pc:spChg chg="add mod">
-          <ac:chgData name="Rich Reba" userId="8245d172-5b81-40f1-a13b-b71f02cd6700" providerId="ADAL" clId="{1F8583C6-4D3D-FC4B-B89E-87F4AA8D44B0}" dt="2024-04-17T12:43:48.128" v="3537"/>
-          <ac:spMkLst>
-            <pc:docMk/>
-            <pc:sldMk cId="3088802820" sldId="272"/>
-            <ac:spMk id="7" creationId="{8FA3F51F-BAA5-391C-B500-D450E50CA7E6}"/>
-          </ac:spMkLst>
-        </pc:spChg>
-        <pc:spChg chg="mod">
-          <ac:chgData name="Rich Reba" userId="8245d172-5b81-40f1-a13b-b71f02cd6700" providerId="ADAL" clId="{1F8583C6-4D3D-FC4B-B89E-87F4AA8D44B0}" dt="2024-04-11T22:22:38.617" v="1076" actId="20577"/>
-          <ac:spMkLst>
-            <pc:docMk/>
-            <pc:sldMk cId="3088802820" sldId="272"/>
-            <ac:spMk id="96" creationId="{00000000-0000-0000-0000-000000000000}"/>
-          </ac:spMkLst>
-        </pc:spChg>
-        <pc:graphicFrameChg chg="del">
-          <ac:chgData name="Rich Reba" userId="8245d172-5b81-40f1-a13b-b71f02cd6700" providerId="ADAL" clId="{1F8583C6-4D3D-FC4B-B89E-87F4AA8D44B0}" dt="2024-04-11T22:22:01.950" v="1066" actId="478"/>
-          <ac:graphicFrameMkLst>
-            <pc:docMk/>
-            <pc:sldMk cId="3088802820" sldId="272"/>
-            <ac:graphicFrameMk id="2" creationId="{59DCEAC8-DB72-C8D9-0DB4-F8D83D801ADB}"/>
-          </ac:graphicFrameMkLst>
-        </pc:graphicFrameChg>
-        <pc:graphicFrameChg chg="add mod modGraphic">
-          <ac:chgData name="Rich Reba" userId="8245d172-5b81-40f1-a13b-b71f02cd6700" providerId="ADAL" clId="{1F8583C6-4D3D-FC4B-B89E-87F4AA8D44B0}" dt="2024-04-11T22:22:26.492" v="1072" actId="14100"/>
-          <ac:graphicFrameMkLst>
-            <pc:docMk/>
-            <pc:sldMk cId="3088802820" sldId="272"/>
-            <ac:graphicFrameMk id="3" creationId="{F1699409-9005-50C8-4771-BC86CF9F9048}"/>
-          </ac:graphicFrameMkLst>
-        </pc:graphicFrameChg>
-      </pc:sldChg>
-      <pc:sldChg chg="modSp add del mod">
-        <pc:chgData name="Rich Reba" userId="8245d172-5b81-40f1-a13b-b71f02cd6700" providerId="ADAL" clId="{1F8583C6-4D3D-FC4B-B89E-87F4AA8D44B0}" dt="2024-04-12T03:35:44.185" v="1880" actId="2696"/>
-        <pc:sldMkLst>
-          <pc:docMk/>
-          <pc:sldMk cId="2427079507" sldId="273"/>
-        </pc:sldMkLst>
-        <pc:spChg chg="mod">
-          <ac:chgData name="Rich Reba" userId="8245d172-5b81-40f1-a13b-b71f02cd6700" providerId="ADAL" clId="{1F8583C6-4D3D-FC4B-B89E-87F4AA8D44B0}" dt="2024-04-11T22:24:45.577" v="1188" actId="20577"/>
-          <ac:spMkLst>
-            <pc:docMk/>
-            <pc:sldMk cId="2427079507" sldId="273"/>
-            <ac:spMk id="2" creationId="{B85FA768-8259-9E0E-4319-23E47B82E0D1}"/>
-          </ac:spMkLst>
-        </pc:spChg>
-      </pc:sldChg>
-      <pc:sldChg chg="modSp add del mod">
-        <pc:chgData name="Rich Reba" userId="8245d172-5b81-40f1-a13b-b71f02cd6700" providerId="ADAL" clId="{1F8583C6-4D3D-FC4B-B89E-87F4AA8D44B0}" dt="2024-04-12T03:35:44.212" v="1888" actId="2696"/>
-        <pc:sldMkLst>
-          <pc:docMk/>
-          <pc:sldMk cId="1168023954" sldId="274"/>
-        </pc:sldMkLst>
-        <pc:spChg chg="mod">
-          <ac:chgData name="Rich Reba" userId="8245d172-5b81-40f1-a13b-b71f02cd6700" providerId="ADAL" clId="{1F8583C6-4D3D-FC4B-B89E-87F4AA8D44B0}" dt="2024-04-12T02:46:34.065" v="1199" actId="20577"/>
-          <ac:spMkLst>
-            <pc:docMk/>
-            <pc:sldMk cId="1168023954" sldId="274"/>
-            <ac:spMk id="96" creationId="{00000000-0000-0000-0000-000000000000}"/>
-          </ac:spMkLst>
-        </pc:spChg>
-        <pc:graphicFrameChg chg="mod modGraphic">
-          <ac:chgData name="Rich Reba" userId="8245d172-5b81-40f1-a13b-b71f02cd6700" providerId="ADAL" clId="{1F8583C6-4D3D-FC4B-B89E-87F4AA8D44B0}" dt="2024-04-12T02:54:52.923" v="1877" actId="20577"/>
-          <ac:graphicFrameMkLst>
-            <pc:docMk/>
-            <pc:sldMk cId="1168023954" sldId="274"/>
-            <ac:graphicFrameMk id="5" creationId="{4B70F3A5-8062-29A2-30D0-2783CB3DFCCA}"/>
-          </ac:graphicFrameMkLst>
-        </pc:graphicFrameChg>
-      </pc:sldChg>
-      <pc:sldChg chg="addSp modSp add del">
-        <pc:chgData name="Rich Reba" userId="8245d172-5b81-40f1-a13b-b71f02cd6700" providerId="ADAL" clId="{1F8583C6-4D3D-FC4B-B89E-87F4AA8D44B0}" dt="2024-04-17T12:43:35.608" v="3531"/>
-        <pc:sldMkLst>
-          <pc:docMk/>
-          <pc:sldMk cId="3864669982" sldId="274"/>
-        </pc:sldMkLst>
-        <pc:spChg chg="add mod">
-          <ac:chgData name="Rich Reba" userId="8245d172-5b81-40f1-a13b-b71f02cd6700" providerId="ADAL" clId="{1F8583C6-4D3D-FC4B-B89E-87F4AA8D44B0}" dt="2024-04-17T12:43:35.608" v="3531"/>
-          <ac:spMkLst>
-            <pc:docMk/>
-            <pc:sldMk cId="3864669982" sldId="274"/>
-            <ac:spMk id="2" creationId="{9794E367-08E9-19A4-4179-45E0D09102EF}"/>
-          </ac:spMkLst>
-        </pc:spChg>
-      </pc:sldChg>
-      <pc:sldChg chg="addSp modSp add del">
-        <pc:chgData name="Rich Reba" userId="8245d172-5b81-40f1-a13b-b71f02cd6700" providerId="ADAL" clId="{1F8583C6-4D3D-FC4B-B89E-87F4AA8D44B0}" dt="2024-04-17T12:43:51.355" v="3539"/>
-        <pc:sldMkLst>
-          <pc:docMk/>
-          <pc:sldMk cId="2639682451" sldId="275"/>
-        </pc:sldMkLst>
-        <pc:spChg chg="add mod">
-          <ac:chgData name="Rich Reba" userId="8245d172-5b81-40f1-a13b-b71f02cd6700" providerId="ADAL" clId="{1F8583C6-4D3D-FC4B-B89E-87F4AA8D44B0}" dt="2024-04-17T12:43:51.355" v="3539"/>
-          <ac:spMkLst>
-            <pc:docMk/>
-            <pc:sldMk cId="2639682451" sldId="275"/>
-            <ac:spMk id="6" creationId="{7C30D5DC-2695-01BA-B05D-C3CC4747D7F4}"/>
-          </ac:spMkLst>
-        </pc:spChg>
-      </pc:sldChg>
-      <pc:sldChg chg="addSp modSp add del">
-        <pc:chgData name="Rich Reba" userId="8245d172-5b81-40f1-a13b-b71f02cd6700" providerId="ADAL" clId="{1F8583C6-4D3D-FC4B-B89E-87F4AA8D44B0}" dt="2024-04-17T12:43:31.935" v="3529"/>
-        <pc:sldMkLst>
-          <pc:docMk/>
-          <pc:sldMk cId="3191730488" sldId="276"/>
-        </pc:sldMkLst>
-        <pc:spChg chg="add mod">
-          <ac:chgData name="Rich Reba" userId="8245d172-5b81-40f1-a13b-b71f02cd6700" providerId="ADAL" clId="{1F8583C6-4D3D-FC4B-B89E-87F4AA8D44B0}" dt="2024-04-17T12:43:31.935" v="3529"/>
-          <ac:spMkLst>
-            <pc:docMk/>
-            <pc:sldMk cId="3191730488" sldId="276"/>
-            <ac:spMk id="2" creationId="{B53C39C2-BA45-92C3-D93B-96BF2FF7E2EA}"/>
-          </ac:spMkLst>
-        </pc:spChg>
-      </pc:sldChg>
-      <pc:sldChg chg="addSp modSp add del">
-        <pc:chgData name="Rich Reba" userId="8245d172-5b81-40f1-a13b-b71f02cd6700" providerId="ADAL" clId="{1F8583C6-4D3D-FC4B-B89E-87F4AA8D44B0}" dt="2024-04-17T12:43:33.370" v="3530"/>
-        <pc:sldMkLst>
-          <pc:docMk/>
-          <pc:sldMk cId="368434212" sldId="277"/>
-        </pc:sldMkLst>
-        <pc:spChg chg="add mod">
-          <ac:chgData name="Rich Reba" userId="8245d172-5b81-40f1-a13b-b71f02cd6700" providerId="ADAL" clId="{1F8583C6-4D3D-FC4B-B89E-87F4AA8D44B0}" dt="2024-04-17T12:43:33.370" v="3530"/>
-          <ac:spMkLst>
-            <pc:docMk/>
-            <pc:sldMk cId="368434212" sldId="277"/>
-            <ac:spMk id="3" creationId="{7EF92490-8763-C122-9420-8771007CA2FA}"/>
-          </ac:spMkLst>
-        </pc:spChg>
-      </pc:sldChg>
-      <pc:sldChg chg="addSp modSp add del">
-        <pc:chgData name="Rich Reba" userId="8245d172-5b81-40f1-a13b-b71f02cd6700" providerId="ADAL" clId="{1F8583C6-4D3D-FC4B-B89E-87F4AA8D44B0}" dt="2024-04-17T12:43:03.339" v="3513"/>
-        <pc:sldMkLst>
-          <pc:docMk/>
-          <pc:sldMk cId="3888112108" sldId="278"/>
-        </pc:sldMkLst>
-        <pc:spChg chg="add mod">
-          <ac:chgData name="Rich Reba" userId="8245d172-5b81-40f1-a13b-b71f02cd6700" providerId="ADAL" clId="{1F8583C6-4D3D-FC4B-B89E-87F4AA8D44B0}" dt="2024-04-17T12:43:03.339" v="3513"/>
-          <ac:spMkLst>
-            <pc:docMk/>
-            <pc:sldMk cId="3888112108" sldId="278"/>
-            <ac:spMk id="2" creationId="{048B8078-0A98-B723-6D07-9C874B8373FA}"/>
-          </ac:spMkLst>
-        </pc:spChg>
-      </pc:sldChg>
-      <pc:sldChg chg="addSp modSp add del">
-        <pc:chgData name="Rich Reba" userId="8245d172-5b81-40f1-a13b-b71f02cd6700" providerId="ADAL" clId="{1F8583C6-4D3D-FC4B-B89E-87F4AA8D44B0}" dt="2024-04-17T12:43:30.471" v="3528"/>
-        <pc:sldMkLst>
-          <pc:docMk/>
-          <pc:sldMk cId="4099550087" sldId="279"/>
-        </pc:sldMkLst>
-        <pc:spChg chg="add mod">
-          <ac:chgData name="Rich Reba" userId="8245d172-5b81-40f1-a13b-b71f02cd6700" providerId="ADAL" clId="{1F8583C6-4D3D-FC4B-B89E-87F4AA8D44B0}" dt="2024-04-17T12:43:30.471" v="3528"/>
-          <ac:spMkLst>
-            <pc:docMk/>
-            <pc:sldMk cId="4099550087" sldId="279"/>
-            <ac:spMk id="6" creationId="{7CAB671F-9BEE-E2C8-B532-9AAC16B0D9FC}"/>
-          </ac:spMkLst>
-        </pc:spChg>
-      </pc:sldChg>
-      <pc:sldChg chg="addSp modSp add del">
-        <pc:chgData name="Rich Reba" userId="8245d172-5b81-40f1-a13b-b71f02cd6700" providerId="ADAL" clId="{1F8583C6-4D3D-FC4B-B89E-87F4AA8D44B0}" dt="2024-04-17T12:43:49.972" v="3538"/>
-        <pc:sldMkLst>
-          <pc:docMk/>
-          <pc:sldMk cId="2970225831" sldId="280"/>
-        </pc:sldMkLst>
-        <pc:spChg chg="add mod">
-          <ac:chgData name="Rich Reba" userId="8245d172-5b81-40f1-a13b-b71f02cd6700" providerId="ADAL" clId="{1F8583C6-4D3D-FC4B-B89E-87F4AA8D44B0}" dt="2024-04-17T12:43:49.972" v="3538"/>
-          <ac:spMkLst>
-            <pc:docMk/>
-            <pc:sldMk cId="2970225831" sldId="280"/>
-            <ac:spMk id="6" creationId="{ED514B9A-C821-414D-27E7-22058443F6B3}"/>
-          </ac:spMkLst>
-        </pc:spChg>
-      </pc:sldChg>
-      <pc:sldMasterChg chg="delSldLayout modSldLayout">
-        <pc:chgData name="Rich Reba" userId="8245d172-5b81-40f1-a13b-b71f02cd6700" providerId="ADAL" clId="{1F8583C6-4D3D-FC4B-B89E-87F4AA8D44B0}" dt="2024-04-17T12:42:54.787" v="3511" actId="20577"/>
-        <pc:sldMasterMkLst>
-          <pc:docMk/>
-          <pc:sldMasterMk cId="0" sldId="2147483648"/>
-        </pc:sldMasterMkLst>
-        <pc:sldLayoutChg chg="modSp mod">
-          <pc:chgData name="Rich Reba" userId="8245d172-5b81-40f1-a13b-b71f02cd6700" providerId="ADAL" clId="{1F8583C6-4D3D-FC4B-B89E-87F4AA8D44B0}" dt="2024-04-17T12:42:54.787" v="3511" actId="20577"/>
-          <pc:sldLayoutMkLst>
-            <pc:docMk/>
-            <pc:sldMasterMk cId="0" sldId="2147483648"/>
-            <pc:sldLayoutMk cId="0" sldId="2147483649"/>
-          </pc:sldLayoutMkLst>
-          <pc:spChg chg="mod">
-            <ac:chgData name="Rich Reba" userId="8245d172-5b81-40f1-a13b-b71f02cd6700" providerId="ADAL" clId="{1F8583C6-4D3D-FC4B-B89E-87F4AA8D44B0}" dt="2024-04-17T12:42:54.787" v="3511" actId="20577"/>
-            <ac:spMkLst>
-              <pc:docMk/>
-              <pc:sldMasterMk cId="0" sldId="2147483648"/>
-              <pc:sldLayoutMk cId="0" sldId="2147483649"/>
-              <ac:spMk id="18" creationId="{00000000-0000-0000-0000-000000000000}"/>
-            </ac:spMkLst>
-          </pc:spChg>
-        </pc:sldLayoutChg>
-        <pc:sldLayoutChg chg="del">
-          <pc:chgData name="Rich Reba" userId="8245d172-5b81-40f1-a13b-b71f02cd6700" providerId="ADAL" clId="{1F8583C6-4D3D-FC4B-B89E-87F4AA8D44B0}" dt="2024-04-11T22:04:52.050" v="75" actId="2696"/>
-          <pc:sldLayoutMkLst>
-            <pc:docMk/>
-            <pc:sldMasterMk cId="0" sldId="2147483648"/>
-            <pc:sldLayoutMk cId="0" sldId="2147483650"/>
-          </pc:sldLayoutMkLst>
-        </pc:sldLayoutChg>
-        <pc:sldLayoutChg chg="del">
-          <pc:chgData name="Rich Reba" userId="8245d172-5b81-40f1-a13b-b71f02cd6700" providerId="ADAL" clId="{1F8583C6-4D3D-FC4B-B89E-87F4AA8D44B0}" dt="2024-04-12T03:35:44.194" v="1884" actId="2696"/>
-          <pc:sldLayoutMkLst>
-            <pc:docMk/>
-            <pc:sldMasterMk cId="0" sldId="2147483648"/>
-            <pc:sldLayoutMk cId="0" sldId="2147483652"/>
-          </pc:sldLayoutMkLst>
-        </pc:sldLayoutChg>
-        <pc:sldLayoutChg chg="del">
-          <pc:chgData name="Rich Reba" userId="8245d172-5b81-40f1-a13b-b71f02cd6700" providerId="ADAL" clId="{1F8583C6-4D3D-FC4B-B89E-87F4AA8D44B0}" dt="2024-04-11T22:04:52.173" v="83" actId="2696"/>
-          <pc:sldLayoutMkLst>
-            <pc:docMk/>
-            <pc:sldMasterMk cId="0" sldId="2147483648"/>
-            <pc:sldLayoutMk cId="0" sldId="2147483653"/>
-          </pc:sldLayoutMkLst>
-        </pc:sldLayoutChg>
-        <pc:sldLayoutChg chg="del">
-          <pc:chgData name="Rich Reba" userId="8245d172-5b81-40f1-a13b-b71f02cd6700" providerId="ADAL" clId="{1F8583C6-4D3D-FC4B-B89E-87F4AA8D44B0}" dt="2024-04-11T22:04:52.058" v="78" actId="2696"/>
-          <pc:sldLayoutMkLst>
-            <pc:docMk/>
-            <pc:sldMasterMk cId="0" sldId="2147483648"/>
-            <pc:sldLayoutMk cId="957704149" sldId="2147483660"/>
-          </pc:sldLayoutMkLst>
-        </pc:sldLayoutChg>
-        <pc:sldLayoutChg chg="del">
-          <pc:chgData name="Rich Reba" userId="8245d172-5b81-40f1-a13b-b71f02cd6700" providerId="ADAL" clId="{1F8583C6-4D3D-FC4B-B89E-87F4AA8D44B0}" dt="2024-04-12T03:35:44.222" v="1890" actId="2696"/>
-          <pc:sldLayoutMkLst>
-            <pc:docMk/>
-            <pc:sldMasterMk cId="0" sldId="2147483648"/>
-            <pc:sldLayoutMk cId="3328410917" sldId="2147483660"/>
-          </pc:sldLayoutMkLst>
-        </pc:sldLayoutChg>
-        <pc:sldLayoutChg chg="del">
-          <pc:chgData name="Rich Reba" userId="8245d172-5b81-40f1-a13b-b71f02cd6700" providerId="ADAL" clId="{1F8583C6-4D3D-FC4B-B89E-87F4AA8D44B0}" dt="2024-04-11T22:13:46.759" v="958" actId="2696"/>
-          <pc:sldLayoutMkLst>
-            <pc:docMk/>
-            <pc:sldMasterMk cId="0" sldId="2147483648"/>
-            <pc:sldLayoutMk cId="2300803375" sldId="2147483661"/>
-          </pc:sldLayoutMkLst>
-        </pc:sldLayoutChg>
-      </pc:sldMasterChg>
-    </pc:docChg>
-  </pc:docChgLst>
-  <pc:docChgLst>
-    <pc:chgData name="Rich Reba" userId="8245d172-5b81-40f1-a13b-b71f02cd6700" providerId="ADAL" clId="{42CC33E3-BD40-6C48-8732-014804D0C36C}"/>
-    <pc:docChg chg="undo custSel modSld">
-      <pc:chgData name="Rich Reba" userId="8245d172-5b81-40f1-a13b-b71f02cd6700" providerId="ADAL" clId="{42CC33E3-BD40-6C48-8732-014804D0C36C}" dt="2024-05-23T19:10:48.403" v="2061" actId="20577"/>
-      <pc:docMkLst>
-        <pc:docMk/>
-      </pc:docMkLst>
-      <pc:sldChg chg="modSp mod">
-        <pc:chgData name="Rich Reba" userId="8245d172-5b81-40f1-a13b-b71f02cd6700" providerId="ADAL" clId="{42CC33E3-BD40-6C48-8732-014804D0C36C}" dt="2024-05-23T16:21:50.961" v="69" actId="20577"/>
-        <pc:sldMkLst>
-          <pc:docMk/>
-          <pc:sldMk cId="1272635936" sldId="264"/>
-        </pc:sldMkLst>
-        <pc:graphicFrameChg chg="modGraphic">
-          <ac:chgData name="Rich Reba" userId="8245d172-5b81-40f1-a13b-b71f02cd6700" providerId="ADAL" clId="{42CC33E3-BD40-6C48-8732-014804D0C36C}" dt="2024-05-23T16:21:50.961" v="69" actId="20577"/>
-          <ac:graphicFrameMkLst>
-            <pc:docMk/>
-            <pc:sldMk cId="1272635936" sldId="264"/>
-            <ac:graphicFrameMk id="5" creationId="{4B70F3A5-8062-29A2-30D0-2783CB3DFCCA}"/>
-          </ac:graphicFrameMkLst>
-        </pc:graphicFrameChg>
-      </pc:sldChg>
-      <pc:sldChg chg="modSp mod">
-        <pc:chgData name="Rich Reba" userId="8245d172-5b81-40f1-a13b-b71f02cd6700" providerId="ADAL" clId="{42CC33E3-BD40-6C48-8732-014804D0C36C}" dt="2024-05-23T16:22:08.070" v="75" actId="20577"/>
-        <pc:sldMkLst>
-          <pc:docMk/>
-          <pc:sldMk cId="1243007551" sldId="268"/>
-        </pc:sldMkLst>
-        <pc:graphicFrameChg chg="modGraphic">
-          <ac:chgData name="Rich Reba" userId="8245d172-5b81-40f1-a13b-b71f02cd6700" providerId="ADAL" clId="{42CC33E3-BD40-6C48-8732-014804D0C36C}" dt="2024-05-23T16:22:08.070" v="75" actId="20577"/>
-          <ac:graphicFrameMkLst>
-            <pc:docMk/>
-            <pc:sldMk cId="1243007551" sldId="268"/>
-            <ac:graphicFrameMk id="2" creationId="{849548E0-A616-4177-21C8-C63119ADCD53}"/>
-          </ac:graphicFrameMkLst>
-        </pc:graphicFrameChg>
-      </pc:sldChg>
-      <pc:sldChg chg="modSp mod">
-        <pc:chgData name="Rich Reba" userId="8245d172-5b81-40f1-a13b-b71f02cd6700" providerId="ADAL" clId="{42CC33E3-BD40-6C48-8732-014804D0C36C}" dt="2024-05-23T18:50:24.296" v="1786" actId="14734"/>
-        <pc:sldMkLst>
-          <pc:docMk/>
-          <pc:sldMk cId="450257364" sldId="269"/>
-        </pc:sldMkLst>
-        <pc:graphicFrameChg chg="mod modGraphic">
-          <ac:chgData name="Rich Reba" userId="8245d172-5b81-40f1-a13b-b71f02cd6700" providerId="ADAL" clId="{42CC33E3-BD40-6C48-8732-014804D0C36C}" dt="2024-05-23T18:50:24.296" v="1786" actId="14734"/>
-          <ac:graphicFrameMkLst>
-            <pc:docMk/>
-            <pc:sldMk cId="450257364" sldId="269"/>
-            <ac:graphicFrameMk id="2" creationId="{849548E0-A616-4177-21C8-C63119ADCD53}"/>
-          </ac:graphicFrameMkLst>
-        </pc:graphicFrameChg>
-      </pc:sldChg>
-      <pc:sldChg chg="modSp mod">
-        <pc:chgData name="Rich Reba" userId="8245d172-5b81-40f1-a13b-b71f02cd6700" providerId="ADAL" clId="{42CC33E3-BD40-6C48-8732-014804D0C36C}" dt="2024-05-23T18:57:04.961" v="1824" actId="20577"/>
-        <pc:sldMkLst>
-          <pc:docMk/>
-          <pc:sldMk cId="4255637138" sldId="270"/>
-        </pc:sldMkLst>
-        <pc:graphicFrameChg chg="mod modGraphic">
-          <ac:chgData name="Rich Reba" userId="8245d172-5b81-40f1-a13b-b71f02cd6700" providerId="ADAL" clId="{42CC33E3-BD40-6C48-8732-014804D0C36C}" dt="2024-05-23T18:57:04.961" v="1824" actId="20577"/>
-          <ac:graphicFrameMkLst>
-            <pc:docMk/>
-            <pc:sldMk cId="4255637138" sldId="270"/>
-            <ac:graphicFrameMk id="3" creationId="{14B79CD4-17D9-A460-45EE-070B6CD3DAFF}"/>
-          </ac:graphicFrameMkLst>
-        </pc:graphicFrameChg>
-      </pc:sldChg>
-      <pc:sldChg chg="modSp mod">
-        <pc:chgData name="Rich Reba" userId="8245d172-5b81-40f1-a13b-b71f02cd6700" providerId="ADAL" clId="{42CC33E3-BD40-6C48-8732-014804D0C36C}" dt="2024-05-23T19:09:39.132" v="2051" actId="14734"/>
-        <pc:sldMkLst>
-          <pc:docMk/>
-          <pc:sldMk cId="67448461" sldId="271"/>
-        </pc:sldMkLst>
-        <pc:graphicFrameChg chg="mod modGraphic">
-          <ac:chgData name="Rich Reba" userId="8245d172-5b81-40f1-a13b-b71f02cd6700" providerId="ADAL" clId="{42CC33E3-BD40-6C48-8732-014804D0C36C}" dt="2024-05-23T19:09:39.132" v="2051" actId="14734"/>
-          <ac:graphicFrameMkLst>
-            <pc:docMk/>
-            <pc:sldMk cId="67448461" sldId="271"/>
-            <ac:graphicFrameMk id="2" creationId="{59DCEAC8-DB72-C8D9-0DB4-F8D83D801ADB}"/>
-          </ac:graphicFrameMkLst>
-        </pc:graphicFrameChg>
-      </pc:sldChg>
-      <pc:sldChg chg="modSp mod">
-        <pc:chgData name="Rich Reba" userId="8245d172-5b81-40f1-a13b-b71f02cd6700" providerId="ADAL" clId="{42CC33E3-BD40-6C48-8732-014804D0C36C}" dt="2024-05-23T19:10:48.403" v="2061" actId="20577"/>
+        <pc:chgData name="Rich Reba" userId="55db41ab6eb3f845" providerId="LiveId" clId="{0E19DA16-244C-5B50-BE0F-52911DD4CA7E}" dt="2026-08-09T19:24:21.846" v="679" actId="20577"/>
         <pc:sldMkLst>
           <pc:docMk/>
           <pc:sldMk cId="3088802820" sldId="272"/>
         </pc:sldMkLst>
         <pc:graphicFrameChg chg="modGraphic">
-          <ac:chgData name="Rich Reba" userId="8245d172-5b81-40f1-a13b-b71f02cd6700" providerId="ADAL" clId="{42CC33E3-BD40-6C48-8732-014804D0C36C}" dt="2024-05-23T19:10:48.403" v="2061" actId="20577"/>
+          <ac:chgData name="Rich Reba" userId="55db41ab6eb3f845" providerId="LiveId" clId="{0E19DA16-244C-5B50-BE0F-52911DD4CA7E}" dt="2026-08-09T19:24:21.846" v="679" actId="20577"/>
           <ac:graphicFrameMkLst>
             <pc:docMk/>
             <pc:sldMk cId="3088802820" sldId="272"/>
@@ -1294,581 +397,19 @@
         </pc:graphicFrameChg>
       </pc:sldChg>
       <pc:sldChg chg="modSp mod">
-        <pc:chgData name="Rich Reba" userId="8245d172-5b81-40f1-a13b-b71f02cd6700" providerId="ADAL" clId="{42CC33E3-BD40-6C48-8732-014804D0C36C}" dt="2024-05-23T17:14:04.094" v="1288" actId="20577"/>
+        <pc:chgData name="Rich Reba" userId="55db41ab6eb3f845" providerId="LiveId" clId="{0E19DA16-244C-5B50-BE0F-52911DD4CA7E}" dt="2026-08-09T19:16:36.022" v="255" actId="20577"/>
         <pc:sldMkLst>
           <pc:docMk/>
-          <pc:sldMk cId="3864669982" sldId="274"/>
+          <pc:sldMk cId="368434212" sldId="277"/>
         </pc:sldMkLst>
-        <pc:graphicFrameChg chg="mod modGraphic">
-          <ac:chgData name="Rich Reba" userId="8245d172-5b81-40f1-a13b-b71f02cd6700" providerId="ADAL" clId="{42CC33E3-BD40-6C48-8732-014804D0C36C}" dt="2024-05-23T17:14:04.094" v="1288" actId="20577"/>
+        <pc:graphicFrameChg chg="modGraphic">
+          <ac:chgData name="Rich Reba" userId="55db41ab6eb3f845" providerId="LiveId" clId="{0E19DA16-244C-5B50-BE0F-52911DD4CA7E}" dt="2026-08-09T19:16:36.022" v="255" actId="20577"/>
           <ac:graphicFrameMkLst>
             <pc:docMk/>
-            <pc:sldMk cId="3864669982" sldId="274"/>
-            <ac:graphicFrameMk id="5" creationId="{4B70F3A5-8062-29A2-30D0-2783CB3DFCCA}"/>
+            <pc:sldMk cId="368434212" sldId="277"/>
+            <ac:graphicFrameMk id="4" creationId="{DF0CCA37-1217-B7D3-8320-72D1D9B53C50}"/>
           </ac:graphicFrameMkLst>
         </pc:graphicFrameChg>
-      </pc:sldChg>
-      <pc:sldChg chg="modSp mod">
-        <pc:chgData name="Rich Reba" userId="8245d172-5b81-40f1-a13b-b71f02cd6700" providerId="ADAL" clId="{42CC33E3-BD40-6C48-8732-014804D0C36C}" dt="2024-05-23T17:01:55.292" v="524" actId="20577"/>
-        <pc:sldMkLst>
-          <pc:docMk/>
-          <pc:sldMk cId="3191730488" sldId="276"/>
-        </pc:sldMkLst>
-        <pc:graphicFrameChg chg="modGraphic">
-          <ac:chgData name="Rich Reba" userId="8245d172-5b81-40f1-a13b-b71f02cd6700" providerId="ADAL" clId="{42CC33E3-BD40-6C48-8732-014804D0C36C}" dt="2024-05-23T17:01:55.292" v="524" actId="20577"/>
-          <ac:graphicFrameMkLst>
-            <pc:docMk/>
-            <pc:sldMk cId="3191730488" sldId="276"/>
-            <ac:graphicFrameMk id="5" creationId="{4B70F3A5-8062-29A2-30D0-2783CB3DFCCA}"/>
-          </ac:graphicFrameMkLst>
-        </pc:graphicFrameChg>
-      </pc:sldChg>
-    </pc:docChg>
-  </pc:docChgLst>
-  <pc:docChgLst>
-    <pc:chgData name="Rich Reba" userId="8245d172-5b81-40f1-a13b-b71f02cd6700" providerId="ADAL" clId="{70084D71-80D0-D64D-8904-3C7A6C7A2D52}"/>
-    <pc:docChg chg="undo custSel addSld delSld modSld sldOrd">
-      <pc:chgData name="Rich Reba" userId="8245d172-5b81-40f1-a13b-b71f02cd6700" providerId="ADAL" clId="{70084D71-80D0-D64D-8904-3C7A6C7A2D52}" dt="2023-09-14T14:06:19.817" v="2154" actId="2696"/>
-      <pc:docMkLst>
-        <pc:docMk/>
-      </pc:docMkLst>
-      <pc:sldChg chg="modSp mod">
-        <pc:chgData name="Rich Reba" userId="8245d172-5b81-40f1-a13b-b71f02cd6700" providerId="ADAL" clId="{70084D71-80D0-D64D-8904-3C7A6C7A2D52}" dt="2023-09-14T12:42:49.792" v="1" actId="20577"/>
-        <pc:sldMkLst>
-          <pc:docMk/>
-          <pc:sldMk cId="3978776499" sldId="258"/>
-        </pc:sldMkLst>
-        <pc:spChg chg="mod">
-          <ac:chgData name="Rich Reba" userId="8245d172-5b81-40f1-a13b-b71f02cd6700" providerId="ADAL" clId="{70084D71-80D0-D64D-8904-3C7A6C7A2D52}" dt="2023-09-14T12:42:49.792" v="1" actId="20577"/>
-          <ac:spMkLst>
-            <pc:docMk/>
-            <pc:sldMk cId="3978776499" sldId="258"/>
-            <ac:spMk id="103" creationId="{00000000-0000-0000-0000-000000000000}"/>
-          </ac:spMkLst>
-        </pc:spChg>
-      </pc:sldChg>
-      <pc:sldChg chg="modSp mod">
-        <pc:chgData name="Rich Reba" userId="8245d172-5b81-40f1-a13b-b71f02cd6700" providerId="ADAL" clId="{70084D71-80D0-D64D-8904-3C7A6C7A2D52}" dt="2023-09-14T12:53:43.185" v="14" actId="20577"/>
-        <pc:sldMkLst>
-          <pc:docMk/>
-          <pc:sldMk cId="0" sldId="259"/>
-        </pc:sldMkLst>
-        <pc:spChg chg="mod">
-          <ac:chgData name="Rich Reba" userId="8245d172-5b81-40f1-a13b-b71f02cd6700" providerId="ADAL" clId="{70084D71-80D0-D64D-8904-3C7A6C7A2D52}" dt="2023-09-14T12:53:43.185" v="14" actId="20577"/>
-          <ac:spMkLst>
-            <pc:docMk/>
-            <pc:sldMk cId="0" sldId="259"/>
-            <ac:spMk id="109" creationId="{00000000-0000-0000-0000-000000000000}"/>
-          </ac:spMkLst>
-        </pc:spChg>
-      </pc:sldChg>
-      <pc:sldChg chg="modSp mod">
-        <pc:chgData name="Rich Reba" userId="8245d172-5b81-40f1-a13b-b71f02cd6700" providerId="ADAL" clId="{70084D71-80D0-D64D-8904-3C7A6C7A2D52}" dt="2023-09-14T14:05:46.725" v="2152" actId="20577"/>
-        <pc:sldMkLst>
-          <pc:docMk/>
-          <pc:sldMk cId="0" sldId="261"/>
-        </pc:sldMkLst>
-        <pc:spChg chg="mod">
-          <ac:chgData name="Rich Reba" userId="8245d172-5b81-40f1-a13b-b71f02cd6700" providerId="ADAL" clId="{70084D71-80D0-D64D-8904-3C7A6C7A2D52}" dt="2023-09-14T14:05:46.725" v="2152" actId="20577"/>
-          <ac:spMkLst>
-            <pc:docMk/>
-            <pc:sldMk cId="0" sldId="261"/>
-            <ac:spMk id="128" creationId="{00000000-0000-0000-0000-000000000000}"/>
-          </ac:spMkLst>
-        </pc:spChg>
-        <pc:spChg chg="mod">
-          <ac:chgData name="Rich Reba" userId="8245d172-5b81-40f1-a13b-b71f02cd6700" providerId="ADAL" clId="{70084D71-80D0-D64D-8904-3C7A6C7A2D52}" dt="2023-09-14T14:04:54.288" v="2129" actId="20577"/>
-          <ac:spMkLst>
-            <pc:docMk/>
-            <pc:sldMk cId="0" sldId="261"/>
-            <ac:spMk id="129" creationId="{00000000-0000-0000-0000-000000000000}"/>
-          </ac:spMkLst>
-        </pc:spChg>
-        <pc:spChg chg="mod">
-          <ac:chgData name="Rich Reba" userId="8245d172-5b81-40f1-a13b-b71f02cd6700" providerId="ADAL" clId="{70084D71-80D0-D64D-8904-3C7A6C7A2D52}" dt="2023-09-14T14:05:05.989" v="2137" actId="20577"/>
-          <ac:spMkLst>
-            <pc:docMk/>
-            <pc:sldMk cId="0" sldId="261"/>
-            <ac:spMk id="130" creationId="{00000000-0000-0000-0000-000000000000}"/>
-          </ac:spMkLst>
-        </pc:spChg>
-      </pc:sldChg>
-      <pc:sldChg chg="addSp delSp modSp">
-        <pc:chgData name="Rich Reba" userId="8245d172-5b81-40f1-a13b-b71f02cd6700" providerId="ADAL" clId="{70084D71-80D0-D64D-8904-3C7A6C7A2D52}" dt="2023-09-14T12:46:55.267" v="4"/>
-        <pc:sldMkLst>
-          <pc:docMk/>
-          <pc:sldMk cId="0" sldId="263"/>
-        </pc:sldMkLst>
-        <pc:picChg chg="add del mod">
-          <ac:chgData name="Rich Reba" userId="8245d172-5b81-40f1-a13b-b71f02cd6700" providerId="ADAL" clId="{70084D71-80D0-D64D-8904-3C7A6C7A2D52}" dt="2023-09-14T12:46:55.267" v="4"/>
-          <ac:picMkLst>
-            <pc:docMk/>
-            <pc:sldMk cId="0" sldId="263"/>
-            <ac:picMk id="2" creationId="{51633E08-8143-99DB-69A7-66FA0353ABE5}"/>
-          </ac:picMkLst>
-        </pc:picChg>
-      </pc:sldChg>
-      <pc:sldChg chg="addSp delSp modSp add mod ord">
-        <pc:chgData name="Rich Reba" userId="8245d172-5b81-40f1-a13b-b71f02cd6700" providerId="ADAL" clId="{70084D71-80D0-D64D-8904-3C7A6C7A2D52}" dt="2023-09-14T14:02:13.723" v="2071" actId="20577"/>
-        <pc:sldMkLst>
-          <pc:docMk/>
-          <pc:sldMk cId="1219461281" sldId="264"/>
-        </pc:sldMkLst>
-        <pc:spChg chg="add del mod">
-          <ac:chgData name="Rich Reba" userId="8245d172-5b81-40f1-a13b-b71f02cd6700" providerId="ADAL" clId="{70084D71-80D0-D64D-8904-3C7A6C7A2D52}" dt="2023-09-14T12:47:53.043" v="10" actId="478"/>
-          <ac:spMkLst>
-            <pc:docMk/>
-            <pc:sldMk cId="1219461281" sldId="264"/>
-            <ac:spMk id="3" creationId="{C5A69C63-0DE4-D21A-E43F-F5208927660C}"/>
-          </ac:spMkLst>
-        </pc:spChg>
-        <pc:spChg chg="add mod">
-          <ac:chgData name="Rich Reba" userId="8245d172-5b81-40f1-a13b-b71f02cd6700" providerId="ADAL" clId="{70084D71-80D0-D64D-8904-3C7A6C7A2D52}" dt="2023-09-14T14:02:13.723" v="2071" actId="20577"/>
-          <ac:spMkLst>
-            <pc:docMk/>
-            <pc:sldMk cId="1219461281" sldId="264"/>
-            <ac:spMk id="4" creationId="{AA562A44-0E33-E8CA-ED5D-F7713100DADD}"/>
-          </ac:spMkLst>
-        </pc:spChg>
-        <pc:spChg chg="add mod">
-          <ac:chgData name="Rich Reba" userId="8245d172-5b81-40f1-a13b-b71f02cd6700" providerId="ADAL" clId="{70084D71-80D0-D64D-8904-3C7A6C7A2D52}" dt="2023-09-14T14:01:43.539" v="2069" actId="20577"/>
-          <ac:spMkLst>
-            <pc:docMk/>
-            <pc:sldMk cId="1219461281" sldId="264"/>
-            <ac:spMk id="5" creationId="{C05208D4-7099-0A2E-B4D6-EE439D39CDFE}"/>
-          </ac:spMkLst>
-        </pc:spChg>
-        <pc:spChg chg="add mod">
-          <ac:chgData name="Rich Reba" userId="8245d172-5b81-40f1-a13b-b71f02cd6700" providerId="ADAL" clId="{70084D71-80D0-D64D-8904-3C7A6C7A2D52}" dt="2023-09-14T13:47:19.212" v="1853" actId="1076"/>
-          <ac:spMkLst>
-            <pc:docMk/>
-            <pc:sldMk cId="1219461281" sldId="264"/>
-            <ac:spMk id="6" creationId="{13627153-E3B8-2B37-5AD6-FA22A9CB8EA2}"/>
-          </ac:spMkLst>
-        </pc:spChg>
-        <pc:spChg chg="add mod">
-          <ac:chgData name="Rich Reba" userId="8245d172-5b81-40f1-a13b-b71f02cd6700" providerId="ADAL" clId="{70084D71-80D0-D64D-8904-3C7A6C7A2D52}" dt="2023-09-14T13:47:19.212" v="1853" actId="1076"/>
-          <ac:spMkLst>
-            <pc:docMk/>
-            <pc:sldMk cId="1219461281" sldId="264"/>
-            <ac:spMk id="7" creationId="{0973AB1E-5306-1B75-FD7F-DABE7A4FDC86}"/>
-          </ac:spMkLst>
-        </pc:spChg>
-        <pc:spChg chg="add del mod">
-          <ac:chgData name="Rich Reba" userId="8245d172-5b81-40f1-a13b-b71f02cd6700" providerId="ADAL" clId="{70084D71-80D0-D64D-8904-3C7A6C7A2D52}" dt="2023-09-14T13:34:49.631" v="1200" actId="478"/>
-          <ac:spMkLst>
-            <pc:docMk/>
-            <pc:sldMk cId="1219461281" sldId="264"/>
-            <ac:spMk id="8" creationId="{FD54FD4E-859B-32A1-BEF6-23683D9DADB0}"/>
-          </ac:spMkLst>
-        </pc:spChg>
-        <pc:spChg chg="add mod">
-          <ac:chgData name="Rich Reba" userId="8245d172-5b81-40f1-a13b-b71f02cd6700" providerId="ADAL" clId="{70084D71-80D0-D64D-8904-3C7A6C7A2D52}" dt="2023-09-14T13:47:19.212" v="1853" actId="1076"/>
-          <ac:spMkLst>
-            <pc:docMk/>
-            <pc:sldMk cId="1219461281" sldId="264"/>
-            <ac:spMk id="9" creationId="{A9086EB7-DB44-638E-0877-D28A7E73B137}"/>
-          </ac:spMkLst>
-        </pc:spChg>
-        <pc:spChg chg="add mod">
-          <ac:chgData name="Rich Reba" userId="8245d172-5b81-40f1-a13b-b71f02cd6700" providerId="ADAL" clId="{70084D71-80D0-D64D-8904-3C7A6C7A2D52}" dt="2023-09-14T14:00:53.399" v="2046" actId="20577"/>
-          <ac:spMkLst>
-            <pc:docMk/>
-            <pc:sldMk cId="1219461281" sldId="264"/>
-            <ac:spMk id="10" creationId="{F763824B-D8E9-2C14-D1E5-391EC2F2D70A}"/>
-          </ac:spMkLst>
-        </pc:spChg>
-        <pc:spChg chg="add del">
-          <ac:chgData name="Rich Reba" userId="8245d172-5b81-40f1-a13b-b71f02cd6700" providerId="ADAL" clId="{70084D71-80D0-D64D-8904-3C7A6C7A2D52}" dt="2023-09-14T13:45:57.181" v="1843" actId="478"/>
-          <ac:spMkLst>
-            <pc:docMk/>
-            <pc:sldMk cId="1219461281" sldId="264"/>
-            <ac:spMk id="11" creationId="{A641D1DD-EBB1-DDEC-13AD-6C7FE154F0C9}"/>
-          </ac:spMkLst>
-        </pc:spChg>
-        <pc:spChg chg="mod">
-          <ac:chgData name="Rich Reba" userId="8245d172-5b81-40f1-a13b-b71f02cd6700" providerId="ADAL" clId="{70084D71-80D0-D64D-8904-3C7A6C7A2D52}" dt="2023-09-14T13:48:21.631" v="1927" actId="20577"/>
-          <ac:spMkLst>
-            <pc:docMk/>
-            <pc:sldMk cId="1219461281" sldId="264"/>
-            <ac:spMk id="108" creationId="{00000000-0000-0000-0000-000000000000}"/>
-          </ac:spMkLst>
-        </pc:spChg>
-        <pc:spChg chg="del">
-          <ac:chgData name="Rich Reba" userId="8245d172-5b81-40f1-a13b-b71f02cd6700" providerId="ADAL" clId="{70084D71-80D0-D64D-8904-3C7A6C7A2D52}" dt="2023-09-14T12:47:51.097" v="9" actId="478"/>
-          <ac:spMkLst>
-            <pc:docMk/>
-            <pc:sldMk cId="1219461281" sldId="264"/>
-            <ac:spMk id="109" creationId="{00000000-0000-0000-0000-000000000000}"/>
-          </ac:spMkLst>
-        </pc:spChg>
-        <pc:picChg chg="add mod">
-          <ac:chgData name="Rich Reba" userId="8245d172-5b81-40f1-a13b-b71f02cd6700" providerId="ADAL" clId="{70084D71-80D0-D64D-8904-3C7A6C7A2D52}" dt="2023-09-14T13:47:19.212" v="1853" actId="1076"/>
-          <ac:picMkLst>
-            <pc:docMk/>
-            <pc:sldMk cId="1219461281" sldId="264"/>
-            <ac:picMk id="2050" creationId="{55D24F1A-7E49-8022-9AE0-06D8E2675ADE}"/>
-          </ac:picMkLst>
-        </pc:picChg>
-        <pc:picChg chg="add del mod">
-          <ac:chgData name="Rich Reba" userId="8245d172-5b81-40f1-a13b-b71f02cd6700" providerId="ADAL" clId="{70084D71-80D0-D64D-8904-3C7A6C7A2D52}" dt="2023-09-14T13:00:18.481" v="266" actId="478"/>
-          <ac:picMkLst>
-            <pc:docMk/>
-            <pc:sldMk cId="1219461281" sldId="264"/>
-            <ac:picMk id="2052" creationId="{88797DAE-91A6-0968-1ABD-9A8CCE4E58E5}"/>
-          </ac:picMkLst>
-        </pc:picChg>
-        <pc:picChg chg="add mod">
-          <ac:chgData name="Rich Reba" userId="8245d172-5b81-40f1-a13b-b71f02cd6700" providerId="ADAL" clId="{70084D71-80D0-D64D-8904-3C7A6C7A2D52}" dt="2023-09-14T13:47:19.212" v="1853" actId="1076"/>
-          <ac:picMkLst>
-            <pc:docMk/>
-            <pc:sldMk cId="1219461281" sldId="264"/>
-            <ac:picMk id="2054" creationId="{D72F5262-05A3-0696-18CB-D0B172993ED8}"/>
-          </ac:picMkLst>
-        </pc:picChg>
-        <pc:picChg chg="add del">
-          <ac:chgData name="Rich Reba" userId="8245d172-5b81-40f1-a13b-b71f02cd6700" providerId="ADAL" clId="{70084D71-80D0-D64D-8904-3C7A6C7A2D52}" dt="2023-09-14T13:22:34.016" v="698" actId="478"/>
-          <ac:picMkLst>
-            <pc:docMk/>
-            <pc:sldMk cId="1219461281" sldId="264"/>
-            <ac:picMk id="2056" creationId="{BDA2095C-71A8-67AB-9AE9-1D53A1204A71}"/>
-          </ac:picMkLst>
-        </pc:picChg>
-        <pc:picChg chg="add del">
-          <ac:chgData name="Rich Reba" userId="8245d172-5b81-40f1-a13b-b71f02cd6700" providerId="ADAL" clId="{70084D71-80D0-D64D-8904-3C7A6C7A2D52}" dt="2023-09-14T13:22:45.391" v="700" actId="478"/>
-          <ac:picMkLst>
-            <pc:docMk/>
-            <pc:sldMk cId="1219461281" sldId="264"/>
-            <ac:picMk id="2058" creationId="{286EF330-D9E4-ED3A-2C99-BFC08C116562}"/>
-          </ac:picMkLst>
-        </pc:picChg>
-        <pc:picChg chg="add mod">
-          <ac:chgData name="Rich Reba" userId="8245d172-5b81-40f1-a13b-b71f02cd6700" providerId="ADAL" clId="{70084D71-80D0-D64D-8904-3C7A6C7A2D52}" dt="2023-09-14T13:47:19.212" v="1853" actId="1076"/>
-          <ac:picMkLst>
-            <pc:docMk/>
-            <pc:sldMk cId="1219461281" sldId="264"/>
-            <ac:picMk id="2060" creationId="{716AE581-A09D-9F9C-1924-179457D9F75A}"/>
-          </ac:picMkLst>
-        </pc:picChg>
-        <pc:picChg chg="add mod">
-          <ac:chgData name="Rich Reba" userId="8245d172-5b81-40f1-a13b-b71f02cd6700" providerId="ADAL" clId="{70084D71-80D0-D64D-8904-3C7A6C7A2D52}" dt="2023-09-14T13:47:19.212" v="1853" actId="1076"/>
-          <ac:picMkLst>
-            <pc:docMk/>
-            <pc:sldMk cId="1219461281" sldId="264"/>
-            <ac:picMk id="2062" creationId="{2A5E75DD-6E6B-FA58-71C4-CAE482C42801}"/>
-          </ac:picMkLst>
-        </pc:picChg>
-        <pc:picChg chg="add mod">
-          <ac:chgData name="Rich Reba" userId="8245d172-5b81-40f1-a13b-b71f02cd6700" providerId="ADAL" clId="{70084D71-80D0-D64D-8904-3C7A6C7A2D52}" dt="2023-09-14T13:47:19.212" v="1853" actId="1076"/>
-          <ac:picMkLst>
-            <pc:docMk/>
-            <pc:sldMk cId="1219461281" sldId="264"/>
-            <ac:picMk id="2064" creationId="{981FCD98-6766-A483-0EA7-EA5325859E51}"/>
-          </ac:picMkLst>
-        </pc:picChg>
-        <pc:picChg chg="add mod">
-          <ac:chgData name="Rich Reba" userId="8245d172-5b81-40f1-a13b-b71f02cd6700" providerId="ADAL" clId="{70084D71-80D0-D64D-8904-3C7A6C7A2D52}" dt="2023-09-14T13:47:19.212" v="1853" actId="1076"/>
-          <ac:picMkLst>
-            <pc:docMk/>
-            <pc:sldMk cId="1219461281" sldId="264"/>
-            <ac:picMk id="2066" creationId="{8DAA758C-2853-034B-48D1-10FE95146289}"/>
-          </ac:picMkLst>
-        </pc:picChg>
-        <pc:picChg chg="add mod">
-          <ac:chgData name="Rich Reba" userId="8245d172-5b81-40f1-a13b-b71f02cd6700" providerId="ADAL" clId="{70084D71-80D0-D64D-8904-3C7A6C7A2D52}" dt="2023-09-14T13:47:19.212" v="1853" actId="1076"/>
-          <ac:picMkLst>
-            <pc:docMk/>
-            <pc:sldMk cId="1219461281" sldId="264"/>
-            <ac:picMk id="2070" creationId="{1EE4932A-6E0A-30B1-6EB7-96DECCD88372}"/>
-          </ac:picMkLst>
-        </pc:picChg>
-        <pc:picChg chg="add mod">
-          <ac:chgData name="Rich Reba" userId="8245d172-5b81-40f1-a13b-b71f02cd6700" providerId="ADAL" clId="{70084D71-80D0-D64D-8904-3C7A6C7A2D52}" dt="2023-09-14T13:47:19.212" v="1853" actId="1076"/>
-          <ac:picMkLst>
-            <pc:docMk/>
-            <pc:sldMk cId="1219461281" sldId="264"/>
-            <ac:picMk id="2074" creationId="{6E446A01-DE66-6C9F-8D96-20D7F8FCF8C5}"/>
-          </ac:picMkLst>
-        </pc:picChg>
-        <pc:picChg chg="add mod">
-          <ac:chgData name="Rich Reba" userId="8245d172-5b81-40f1-a13b-b71f02cd6700" providerId="ADAL" clId="{70084D71-80D0-D64D-8904-3C7A6C7A2D52}" dt="2023-09-14T13:47:19.212" v="1853" actId="1076"/>
-          <ac:picMkLst>
-            <pc:docMk/>
-            <pc:sldMk cId="1219461281" sldId="264"/>
-            <ac:picMk id="2076" creationId="{5A0E714D-4FD1-125E-C0A3-5072FBB94806}"/>
-          </ac:picMkLst>
-        </pc:picChg>
-        <pc:picChg chg="add mod">
-          <ac:chgData name="Rich Reba" userId="8245d172-5b81-40f1-a13b-b71f02cd6700" providerId="ADAL" clId="{70084D71-80D0-D64D-8904-3C7A6C7A2D52}" dt="2023-09-14T13:59:55.664" v="1977" actId="12789"/>
-          <ac:picMkLst>
-            <pc:docMk/>
-            <pc:sldMk cId="1219461281" sldId="264"/>
-            <ac:picMk id="2078" creationId="{4078615B-F578-3D50-766D-F3058737ACB7}"/>
-          </ac:picMkLst>
-        </pc:picChg>
-        <pc:picChg chg="add mod">
-          <ac:chgData name="Rich Reba" userId="8245d172-5b81-40f1-a13b-b71f02cd6700" providerId="ADAL" clId="{70084D71-80D0-D64D-8904-3C7A6C7A2D52}" dt="2023-09-14T13:59:55.664" v="1977" actId="12789"/>
-          <ac:picMkLst>
-            <pc:docMk/>
-            <pc:sldMk cId="1219461281" sldId="264"/>
-            <ac:picMk id="2080" creationId="{03A08439-7A3A-03DD-EAC8-246BCCD07654}"/>
-          </ac:picMkLst>
-        </pc:picChg>
-        <pc:picChg chg="add mod">
-          <ac:chgData name="Rich Reba" userId="8245d172-5b81-40f1-a13b-b71f02cd6700" providerId="ADAL" clId="{70084D71-80D0-D64D-8904-3C7A6C7A2D52}" dt="2023-09-14T14:00:01.229" v="1982" actId="1035"/>
-          <ac:picMkLst>
-            <pc:docMk/>
-            <pc:sldMk cId="1219461281" sldId="264"/>
-            <ac:picMk id="2082" creationId="{73865A73-797D-5606-C5C3-DB1A51968EED}"/>
-          </ac:picMkLst>
-        </pc:picChg>
-        <pc:picChg chg="add mod">
-          <ac:chgData name="Rich Reba" userId="8245d172-5b81-40f1-a13b-b71f02cd6700" providerId="ADAL" clId="{70084D71-80D0-D64D-8904-3C7A6C7A2D52}" dt="2023-09-14T14:00:01.229" v="1982" actId="1035"/>
-          <ac:picMkLst>
-            <pc:docMk/>
-            <pc:sldMk cId="1219461281" sldId="264"/>
-            <ac:picMk id="2084" creationId="{AA2BC457-FDC5-87FE-7D2F-85001DCE44CC}"/>
-          </ac:picMkLst>
-        </pc:picChg>
-        <pc:picChg chg="add mod">
-          <ac:chgData name="Rich Reba" userId="8245d172-5b81-40f1-a13b-b71f02cd6700" providerId="ADAL" clId="{70084D71-80D0-D64D-8904-3C7A6C7A2D52}" dt="2023-09-14T13:59:44.028" v="1975" actId="12789"/>
-          <ac:picMkLst>
-            <pc:docMk/>
-            <pc:sldMk cId="1219461281" sldId="264"/>
-            <ac:picMk id="2086" creationId="{7FD08F90-3DDC-E620-8612-F0448AF6C78F}"/>
-          </ac:picMkLst>
-        </pc:picChg>
-        <pc:picChg chg="add mod">
-          <ac:chgData name="Rich Reba" userId="8245d172-5b81-40f1-a13b-b71f02cd6700" providerId="ADAL" clId="{70084D71-80D0-D64D-8904-3C7A6C7A2D52}" dt="2023-09-14T13:59:44.028" v="1975" actId="12789"/>
-          <ac:picMkLst>
-            <pc:docMk/>
-            <pc:sldMk cId="1219461281" sldId="264"/>
-            <ac:picMk id="2088" creationId="{6E40061C-32A0-AE80-8264-0C03D11B1B32}"/>
-          </ac:picMkLst>
-        </pc:picChg>
-        <pc:picChg chg="add mod">
-          <ac:chgData name="Rich Reba" userId="8245d172-5b81-40f1-a13b-b71f02cd6700" providerId="ADAL" clId="{70084D71-80D0-D64D-8904-3C7A6C7A2D52}" dt="2023-09-14T14:00:07.722" v="1986" actId="1035"/>
-          <ac:picMkLst>
-            <pc:docMk/>
-            <pc:sldMk cId="1219461281" sldId="264"/>
-            <ac:picMk id="2090" creationId="{C0ED25BD-2556-A8E8-F996-E487FD033A19}"/>
-          </ac:picMkLst>
-        </pc:picChg>
-        <pc:picChg chg="add mod">
-          <ac:chgData name="Rich Reba" userId="8245d172-5b81-40f1-a13b-b71f02cd6700" providerId="ADAL" clId="{70084D71-80D0-D64D-8904-3C7A6C7A2D52}" dt="2023-09-14T14:00:07.722" v="1986" actId="1035"/>
-          <ac:picMkLst>
-            <pc:docMk/>
-            <pc:sldMk cId="1219461281" sldId="264"/>
-            <ac:picMk id="2092" creationId="{2D0954AE-A95D-8D1F-2859-5F17F1AA1F29}"/>
-          </ac:picMkLst>
-        </pc:picChg>
-      </pc:sldChg>
-      <pc:sldChg chg="addSp delSp modSp new del mod modClrScheme chgLayout">
-        <pc:chgData name="Rich Reba" userId="8245d172-5b81-40f1-a13b-b71f02cd6700" providerId="ADAL" clId="{70084D71-80D0-D64D-8904-3C7A6C7A2D52}" dt="2023-09-14T14:06:19.812" v="2153" actId="2696"/>
-        <pc:sldMkLst>
-          <pc:docMk/>
-          <pc:sldMk cId="3554767061" sldId="265"/>
-        </pc:sldMkLst>
-        <pc:spChg chg="del">
-          <ac:chgData name="Rich Reba" userId="8245d172-5b81-40f1-a13b-b71f02cd6700" providerId="ADAL" clId="{70084D71-80D0-D64D-8904-3C7A6C7A2D52}" dt="2023-09-14T12:47:10.145" v="6" actId="700"/>
-          <ac:spMkLst>
-            <pc:docMk/>
-            <pc:sldMk cId="3554767061" sldId="265"/>
-            <ac:spMk id="2" creationId="{965EF33D-2C50-991F-A38E-0D6462ECB753}"/>
-          </ac:spMkLst>
-        </pc:spChg>
-        <pc:spChg chg="del">
-          <ac:chgData name="Rich Reba" userId="8245d172-5b81-40f1-a13b-b71f02cd6700" providerId="ADAL" clId="{70084D71-80D0-D64D-8904-3C7A6C7A2D52}" dt="2023-09-14T12:47:10.145" v="6" actId="700"/>
-          <ac:spMkLst>
-            <pc:docMk/>
-            <pc:sldMk cId="3554767061" sldId="265"/>
-            <ac:spMk id="3" creationId="{88A8F5B4-51C8-5394-8A9B-731BB20CA1D3}"/>
-          </ac:spMkLst>
-        </pc:spChg>
-        <pc:picChg chg="add mod">
-          <ac:chgData name="Rich Reba" userId="8245d172-5b81-40f1-a13b-b71f02cd6700" providerId="ADAL" clId="{70084D71-80D0-D64D-8904-3C7A6C7A2D52}" dt="2023-09-14T12:47:16.538" v="8" actId="1076"/>
-          <ac:picMkLst>
-            <pc:docMk/>
-            <pc:sldMk cId="3554767061" sldId="265"/>
-            <ac:picMk id="4" creationId="{408518A3-1CB6-FE68-E036-7640C7947211}"/>
-          </ac:picMkLst>
-        </pc:picChg>
-      </pc:sldChg>
-      <pc:sldMasterChg chg="delSldLayout">
-        <pc:chgData name="Rich Reba" userId="8245d172-5b81-40f1-a13b-b71f02cd6700" providerId="ADAL" clId="{70084D71-80D0-D64D-8904-3C7A6C7A2D52}" dt="2023-09-14T14:06:19.817" v="2154" actId="2696"/>
-        <pc:sldMasterMkLst>
-          <pc:docMk/>
-          <pc:sldMasterMk cId="0" sldId="2147483648"/>
-        </pc:sldMasterMkLst>
-        <pc:sldLayoutChg chg="del">
-          <pc:chgData name="Rich Reba" userId="8245d172-5b81-40f1-a13b-b71f02cd6700" providerId="ADAL" clId="{70084D71-80D0-D64D-8904-3C7A6C7A2D52}" dt="2023-09-14T14:06:19.817" v="2154" actId="2696"/>
-          <pc:sldLayoutMkLst>
-            <pc:docMk/>
-            <pc:sldMasterMk cId="0" sldId="2147483648"/>
-            <pc:sldLayoutMk cId="0" sldId="2147483655"/>
-          </pc:sldLayoutMkLst>
-        </pc:sldLayoutChg>
-      </pc:sldMasterChg>
-    </pc:docChg>
-  </pc:docChgLst>
-  <pc:docChgLst>
-    <pc:chgData name="Rich Reba" userId="8245d172-5b81-40f1-a13b-b71f02cd6700" providerId="ADAL" clId="{114B7AA1-CF7E-5D4E-B028-77ABD5A6FFAB}"/>
-    <pc:docChg chg="modSld">
-      <pc:chgData name="Rich Reba" userId="8245d172-5b81-40f1-a13b-b71f02cd6700" providerId="ADAL" clId="{114B7AA1-CF7E-5D4E-B028-77ABD5A6FFAB}" dt="2024-09-05T16:07:51.144" v="564" actId="14734"/>
-      <pc:docMkLst>
-        <pc:docMk/>
-      </pc:docMkLst>
-      <pc:sldChg chg="modSp mod">
-        <pc:chgData name="Rich Reba" userId="8245d172-5b81-40f1-a13b-b71f02cd6700" providerId="ADAL" clId="{114B7AA1-CF7E-5D4E-B028-77ABD5A6FFAB}" dt="2024-09-05T13:00:41.822" v="10" actId="20577"/>
-        <pc:sldMkLst>
-          <pc:docMk/>
-          <pc:sldMk cId="0" sldId="256"/>
-        </pc:sldMkLst>
-        <pc:spChg chg="mod">
-          <ac:chgData name="Rich Reba" userId="8245d172-5b81-40f1-a13b-b71f02cd6700" providerId="ADAL" clId="{114B7AA1-CF7E-5D4E-B028-77ABD5A6FFAB}" dt="2024-09-05T13:00:41.822" v="10" actId="20577"/>
-          <ac:spMkLst>
-            <pc:docMk/>
-            <pc:sldMk cId="0" sldId="256"/>
-            <ac:spMk id="91" creationId="{00000000-0000-0000-0000-000000000000}"/>
-          </ac:spMkLst>
-        </pc:spChg>
-      </pc:sldChg>
-      <pc:sldChg chg="modSp mod">
-        <pc:chgData name="Rich Reba" userId="8245d172-5b81-40f1-a13b-b71f02cd6700" providerId="ADAL" clId="{114B7AA1-CF7E-5D4E-B028-77ABD5A6FFAB}" dt="2024-09-05T16:01:06.073" v="418" actId="20577"/>
-        <pc:sldMkLst>
-          <pc:docMk/>
-          <pc:sldMk cId="1272635936" sldId="264"/>
-        </pc:sldMkLst>
-        <pc:graphicFrameChg chg="mod modGraphic">
-          <ac:chgData name="Rich Reba" userId="8245d172-5b81-40f1-a13b-b71f02cd6700" providerId="ADAL" clId="{114B7AA1-CF7E-5D4E-B028-77ABD5A6FFAB}" dt="2024-09-05T16:01:06.073" v="418" actId="20577"/>
-          <ac:graphicFrameMkLst>
-            <pc:docMk/>
-            <pc:sldMk cId="1272635936" sldId="264"/>
-            <ac:graphicFrameMk id="5" creationId="{4B70F3A5-8062-29A2-30D0-2783CB3DFCCA}"/>
-          </ac:graphicFrameMkLst>
-        </pc:graphicFrameChg>
-      </pc:sldChg>
-      <pc:sldChg chg="addSp delSp modSp mod">
-        <pc:chgData name="Rich Reba" userId="8245d172-5b81-40f1-a13b-b71f02cd6700" providerId="ADAL" clId="{114B7AA1-CF7E-5D4E-B028-77ABD5A6FFAB}" dt="2024-09-05T16:05:49.071" v="562" actId="20577"/>
-        <pc:sldMkLst>
-          <pc:docMk/>
-          <pc:sldMk cId="1243007551" sldId="268"/>
-        </pc:sldMkLst>
-        <pc:spChg chg="add del mod">
-          <ac:chgData name="Rich Reba" userId="8245d172-5b81-40f1-a13b-b71f02cd6700" providerId="ADAL" clId="{114B7AA1-CF7E-5D4E-B028-77ABD5A6FFAB}" dt="2024-09-05T13:05:02.202" v="47"/>
-          <ac:spMkLst>
-            <pc:docMk/>
-            <pc:sldMk cId="1243007551" sldId="268"/>
-            <ac:spMk id="7" creationId="{762EC1C3-068F-4BCC-6B50-B969C07FBD34}"/>
-          </ac:spMkLst>
-        </pc:spChg>
-        <pc:graphicFrameChg chg="mod modGraphic">
-          <ac:chgData name="Rich Reba" userId="8245d172-5b81-40f1-a13b-b71f02cd6700" providerId="ADAL" clId="{114B7AA1-CF7E-5D4E-B028-77ABD5A6FFAB}" dt="2024-09-05T16:05:49.071" v="562" actId="20577"/>
-          <ac:graphicFrameMkLst>
-            <pc:docMk/>
-            <pc:sldMk cId="1243007551" sldId="268"/>
-            <ac:graphicFrameMk id="2" creationId="{849548E0-A616-4177-21C8-C63119ADCD53}"/>
-          </ac:graphicFrameMkLst>
-        </pc:graphicFrameChg>
-      </pc:sldChg>
-      <pc:sldChg chg="modSp mod">
-        <pc:chgData name="Rich Reba" userId="8245d172-5b81-40f1-a13b-b71f02cd6700" providerId="ADAL" clId="{114B7AA1-CF7E-5D4E-B028-77ABD5A6FFAB}" dt="2024-09-05T13:01:50.129" v="23" actId="113"/>
-        <pc:sldMkLst>
-          <pc:docMk/>
-          <pc:sldMk cId="450257364" sldId="269"/>
-        </pc:sldMkLst>
-        <pc:graphicFrameChg chg="modGraphic">
-          <ac:chgData name="Rich Reba" userId="8245d172-5b81-40f1-a13b-b71f02cd6700" providerId="ADAL" clId="{114B7AA1-CF7E-5D4E-B028-77ABD5A6FFAB}" dt="2024-09-05T13:01:50.129" v="23" actId="113"/>
-          <ac:graphicFrameMkLst>
-            <pc:docMk/>
-            <pc:sldMk cId="450257364" sldId="269"/>
-            <ac:graphicFrameMk id="2" creationId="{849548E0-A616-4177-21C8-C63119ADCD53}"/>
-          </ac:graphicFrameMkLst>
-        </pc:graphicFrameChg>
-      </pc:sldChg>
-      <pc:sldChg chg="modSp mod">
-        <pc:chgData name="Rich Reba" userId="8245d172-5b81-40f1-a13b-b71f02cd6700" providerId="ADAL" clId="{114B7AA1-CF7E-5D4E-B028-77ABD5A6FFAB}" dt="2024-09-05T16:07:51.144" v="564" actId="14734"/>
-        <pc:sldMkLst>
-          <pc:docMk/>
-          <pc:sldMk cId="4255637138" sldId="270"/>
-        </pc:sldMkLst>
-        <pc:graphicFrameChg chg="modGraphic">
-          <ac:chgData name="Rich Reba" userId="8245d172-5b81-40f1-a13b-b71f02cd6700" providerId="ADAL" clId="{114B7AA1-CF7E-5D4E-B028-77ABD5A6FFAB}" dt="2024-09-05T16:07:51.144" v="564" actId="14734"/>
-          <ac:graphicFrameMkLst>
-            <pc:docMk/>
-            <pc:sldMk cId="4255637138" sldId="270"/>
-            <ac:graphicFrameMk id="3" creationId="{14B79CD4-17D9-A460-45EE-070B6CD3DAFF}"/>
-          </ac:graphicFrameMkLst>
-        </pc:graphicFrameChg>
-      </pc:sldChg>
-      <pc:sldChg chg="modSp mod">
-        <pc:chgData name="Rich Reba" userId="8245d172-5b81-40f1-a13b-b71f02cd6700" providerId="ADAL" clId="{114B7AA1-CF7E-5D4E-B028-77ABD5A6FFAB}" dt="2024-09-05T13:03:17.404" v="40" actId="113"/>
-        <pc:sldMkLst>
-          <pc:docMk/>
-          <pc:sldMk cId="67448461" sldId="271"/>
-        </pc:sldMkLst>
-        <pc:graphicFrameChg chg="modGraphic">
-          <ac:chgData name="Rich Reba" userId="8245d172-5b81-40f1-a13b-b71f02cd6700" providerId="ADAL" clId="{114B7AA1-CF7E-5D4E-B028-77ABD5A6FFAB}" dt="2024-09-05T13:03:17.404" v="40" actId="113"/>
-          <ac:graphicFrameMkLst>
-            <pc:docMk/>
-            <pc:sldMk cId="67448461" sldId="271"/>
-            <ac:graphicFrameMk id="2" creationId="{59DCEAC8-DB72-C8D9-0DB4-F8D83D801ADB}"/>
-          </ac:graphicFrameMkLst>
-        </pc:graphicFrameChg>
-      </pc:sldChg>
-      <pc:sldChg chg="modSp mod">
-        <pc:chgData name="Rich Reba" userId="8245d172-5b81-40f1-a13b-b71f02cd6700" providerId="ADAL" clId="{114B7AA1-CF7E-5D4E-B028-77ABD5A6FFAB}" dt="2024-09-05T13:03:35.571" v="44" actId="113"/>
-        <pc:sldMkLst>
-          <pc:docMk/>
-          <pc:sldMk cId="3088802820" sldId="272"/>
-        </pc:sldMkLst>
-        <pc:graphicFrameChg chg="modGraphic">
-          <ac:chgData name="Rich Reba" userId="8245d172-5b81-40f1-a13b-b71f02cd6700" providerId="ADAL" clId="{114B7AA1-CF7E-5D4E-B028-77ABD5A6FFAB}" dt="2024-09-05T13:03:35.571" v="44" actId="113"/>
-          <ac:graphicFrameMkLst>
-            <pc:docMk/>
-            <pc:sldMk cId="3088802820" sldId="272"/>
-            <ac:graphicFrameMk id="3" creationId="{F1699409-9005-50C8-4771-BC86CF9F9048}"/>
-          </ac:graphicFrameMkLst>
-        </pc:graphicFrameChg>
-      </pc:sldChg>
-      <pc:sldChg chg="modSp mod">
-        <pc:chgData name="Rich Reba" userId="8245d172-5b81-40f1-a13b-b71f02cd6700" providerId="ADAL" clId="{114B7AA1-CF7E-5D4E-B028-77ABD5A6FFAB}" dt="2024-09-05T16:02:56.976" v="483" actId="20577"/>
-        <pc:sldMkLst>
-          <pc:docMk/>
-          <pc:sldMk cId="3864669982" sldId="274"/>
-        </pc:sldMkLst>
-        <pc:graphicFrameChg chg="modGraphic">
-          <ac:chgData name="Rich Reba" userId="8245d172-5b81-40f1-a13b-b71f02cd6700" providerId="ADAL" clId="{114B7AA1-CF7E-5D4E-B028-77ABD5A6FFAB}" dt="2024-09-05T16:02:56.976" v="483" actId="20577"/>
-          <ac:graphicFrameMkLst>
-            <pc:docMk/>
-            <pc:sldMk cId="3864669982" sldId="274"/>
-            <ac:graphicFrameMk id="5" creationId="{4B70F3A5-8062-29A2-30D0-2783CB3DFCCA}"/>
-          </ac:graphicFrameMkLst>
-        </pc:graphicFrameChg>
-      </pc:sldChg>
-    </pc:docChg>
-  </pc:docChgLst>
-  <pc:docChgLst>
-    <pc:chgData name="Rich Reba" userId="8245d172-5b81-40f1-a13b-b71f02cd6700" providerId="ADAL" clId="{F858A462-7A92-D84E-AB3C-5FDFD3902F04}"/>
-    <pc:docChg chg="modSld">
-      <pc:chgData name="Rich Reba" userId="8245d172-5b81-40f1-a13b-b71f02cd6700" providerId="ADAL" clId="{F858A462-7A92-D84E-AB3C-5FDFD3902F04}" dt="2024-01-26T15:00:11.248" v="13" actId="20577"/>
-      <pc:docMkLst>
-        <pc:docMk/>
-      </pc:docMkLst>
-      <pc:sldChg chg="modSp mod">
-        <pc:chgData name="Rich Reba" userId="8245d172-5b81-40f1-a13b-b71f02cd6700" providerId="ADAL" clId="{F858A462-7A92-D84E-AB3C-5FDFD3902F04}" dt="2024-01-26T15:00:11.248" v="13" actId="20577"/>
-        <pc:sldMkLst>
-          <pc:docMk/>
-          <pc:sldMk cId="0" sldId="256"/>
-        </pc:sldMkLst>
-        <pc:spChg chg="mod">
-          <ac:chgData name="Rich Reba" userId="8245d172-5b81-40f1-a13b-b71f02cd6700" providerId="ADAL" clId="{F858A462-7A92-D84E-AB3C-5FDFD3902F04}" dt="2024-01-26T15:00:11.248" v="13" actId="20577"/>
-          <ac:spMkLst>
-            <pc:docMk/>
-            <pc:sldMk cId="0" sldId="256"/>
-            <ac:spMk id="91" creationId="{00000000-0000-0000-0000-000000000000}"/>
-          </ac:spMkLst>
-        </pc:spChg>
       </pc:sldChg>
     </pc:docChg>
   </pc:docChgLst>
@@ -17427,7 +15968,7 @@
             </a:pPr>
             <a:r>
               <a:rPr lang="en-US" dirty="0"/>
-              <a:t>Rich Reba, President</a:t>
+              <a:t>Professional Networking Service Leader</a:t>
             </a:r>
           </a:p>
           <a:p>
@@ -17449,7 +15990,7 @@
             </a:pPr>
             <a:r>
               <a:rPr lang="en-US" dirty="0"/>
-              <a:t>November 1, 2024</a:t>
+              <a:t>August 9, 2026</a:t>
             </a:r>
           </a:p>
         </p:txBody>
@@ -17687,7 +16228,7 @@
           <p:nvPr>
             <p:extLst>
               <p:ext uri="{D42A27DB-BD31-4B8C-83A1-F6EECF244321}">
-                <p14:modId xmlns:p14="http://schemas.microsoft.com/office/powerpoint/2010/main" val="3072664858"/>
+                <p14:modId xmlns:p14="http://schemas.microsoft.com/office/powerpoint/2010/main" val="4008540820"/>
               </p:ext>
             </p:extLst>
           </p:nvPr>
@@ -17837,7 +16378,7 @@
                           </a:solidFill>
                           <a:effectLst/>
                         </a:rPr>
-                        <a:t> among a Professional Network of 1,000+ initial collaborators while harnessing </a:t>
+                        <a:t> among a Professional Network of 1,000+ initial subscribers while harnessing </a:t>
                       </a:r>
                       <a:r>
                         <a:rPr lang="en-US" sz="1100" b="1" dirty="0">
@@ -18009,7 +16550,7 @@
                           </a:solidFill>
                           <a:effectLst/>
                         </a:rPr>
-                        <a:t>Demand Generation, Customer Acquisition, and Service Fulfillment for our MVP should be focused on attracting and retaining 1,000+ initial collaborators, all who are Net Promoters of the Consortium’s services and its core premise.  As our Service mature beyond MVP, and we find new revenue sources, we will be able to invest in more sophisticated Demand Generation, Customer Acquisition, and Service Fulfillment activities to further accelerate growth and impact.</a:t>
+                        <a:t>Demand Generation, Customer Acquisition, and Service Fulfillment for our MVP should be focused on attracting and retaining 1,000+ initial subscribers, all who are Net Promoters of the Consortium’s services and its core premise.  As our Service mature beyond MVP, and we find new revenue sources, we will be able to invest in more sophisticated Demand Generation, Beneficiary Engagement, and Delivery of Service activities to further accelerate growth and impact.</a:t>
                       </a:r>
                     </a:p>
                   </a:txBody>
@@ -18132,7 +16673,7 @@
                           </a:solidFill>
                           <a:effectLst/>
                         </a:rPr>
-                        <a:t>An opportunity cost of one 10% fraction of Rich Reba’s time for 2 months, which is equivalent to $10K.</a:t>
+                        <a:t>Estimate:  $10K</a:t>
                       </a:r>
                       <a:endParaRPr lang="en-US" sz="1100" dirty="0">
                         <a:solidFill>
@@ -18305,7 +16846,7 @@
                           </a:solidFill>
                           <a:effectLst/>
                         </a:rPr>
-                        <a:t>Leading Indicators:  Increasing numbers of collaborators in the Professional Network, tripling every 2-3 years</a:t>
+                        <a:t>Leading Indicators:  Increasing numbers of subscribers in the Professional Network, tripling every 2-3 years</a:t>
                       </a:r>
                       <a:br>
                         <a:rPr lang="en-US" sz="1100" dirty="0">
@@ -18328,7 +16869,7 @@
                           <a:ea typeface="MS Mincho" panose="02020609040205080304" pitchFamily="49" charset="-128"/>
                           <a:cs typeface="Arial" panose="020B0604020202020204" pitchFamily="34" charset="0"/>
                         </a:rPr>
-                        <a:t>Lagging indicators:  Increasing benefit to collaborators, the Tech Services industry, and humanity, as measured by stakeholder surveys</a:t>
+                        <a:t>Lagging indicators:  Increasing benefit to subscribers, the Tech Services industry, and humanity, as measured by stakeholder surveys</a:t>
                       </a:r>
                       <a:endParaRPr lang="en-US" sz="1100" dirty="0">
                         <a:solidFill>
@@ -18954,7 +17495,7 @@
           <p:nvPr>
             <p:extLst>
               <p:ext uri="{D42A27DB-BD31-4B8C-83A1-F6EECF244321}">
-                <p14:modId xmlns:p14="http://schemas.microsoft.com/office/powerpoint/2010/main" val="1896931182"/>
+                <p14:modId xmlns:p14="http://schemas.microsoft.com/office/powerpoint/2010/main" val="2428508807"/>
               </p:ext>
             </p:extLst>
           </p:nvPr>
@@ -19094,7 +17635,7 @@
                           </a:solidFill>
                           <a:effectLst/>
                         </a:rPr>
-                        <a:t> Service Strategy, Context, Intent, Development Kit, Demand Generation Kit, Customer Acquisition Kit, and Service Fulfillment Kit</a:t>
+                        <a:t> Service Strategy, Context, Intent, Development Kit, Demand Generation Kit, Beneficiary Engagement Kit, and Delivery of Service Kit</a:t>
                       </a:r>
                       <a:br>
                         <a:rPr lang="en-US" sz="1100" dirty="0">
@@ -19358,7 +17899,7 @@
                           <a:ea typeface="MS Mincho" panose="02020609040205080304" pitchFamily="49" charset="-128"/>
                           <a:cs typeface="Arial" panose="020B0604020202020204" pitchFamily="34" charset="0"/>
                         </a:rPr>
-                        <a:t>Features of the AccelRR8 Framework open methodology and the AccelRR8 Body of Knowledge Overview MVPs (v1) will be developed before they are needed by the Consortium’s Professional Networking Service v1.</a:t>
+                        <a:t>Required features of the AccelRR8 Framework open methodology and the AccelRR8 Body of Knowledge Overview MVPs (v1) will be developed before they are needed by the Consortium’s Professional Networking Service v1.</a:t>
                       </a:r>
                     </a:p>
                   </a:txBody>
@@ -19966,7 +18507,7 @@
           <p:nvPr>
             <p:extLst>
               <p:ext uri="{D42A27DB-BD31-4B8C-83A1-F6EECF244321}">
-                <p14:modId xmlns:p14="http://schemas.microsoft.com/office/powerpoint/2010/main" val="140302330"/>
+                <p14:modId xmlns:p14="http://schemas.microsoft.com/office/powerpoint/2010/main" val="1356048251"/>
               </p:ext>
             </p:extLst>
           </p:nvPr>
@@ -20221,7 +18762,7 @@
                           </a:solidFill>
                           <a:effectLst/>
                         </a:rPr>
-                        <a:t> produced by the AccelRR8 Consortium Non-Profit</a:t>
+                        <a:t> produced by AccelRR8 LLC</a:t>
                       </a:r>
                     </a:p>
                     <a:p>
@@ -23261,7 +21802,7 @@
           <p:nvPr>
             <p:extLst>
               <p:ext uri="{D42A27DB-BD31-4B8C-83A1-F6EECF244321}">
-                <p14:modId xmlns:p14="http://schemas.microsoft.com/office/powerpoint/2010/main" val="2368350603"/>
+                <p14:modId xmlns:p14="http://schemas.microsoft.com/office/powerpoint/2010/main" val="3426140323"/>
               </p:ext>
             </p:extLst>
           </p:nvPr>
@@ -23694,7 +22235,7 @@
                           <a:cs typeface="+mn-cs"/>
                           <a:sym typeface="Arial"/>
                         </a:rPr>
-                        <a:t>, value for all collaborators grows exponentially as their numbers grow linearly.</a:t>
+                        <a:t>, value for all subscribers grows exponentially as their numbers grow linearly.</a:t>
                       </a:r>
                     </a:p>
                   </a:txBody>
@@ -23732,7 +22273,7 @@
                       </a:pPr>
                       <a:r>
                         <a:rPr lang="en-US" b="1" dirty="0"/>
-                        <a:t>Collaborators</a:t>
+                        <a:t>Subscribers</a:t>
                       </a:r>
                       <a:r>
                         <a:rPr lang="en-US" dirty="0"/>
@@ -23807,7 +22348,7 @@
                     <a:p>
                       <a:r>
                         <a:rPr lang="en-US" dirty="0"/>
-                        <a:t>1000 collaborators in the AccelRR8 professional network who are net promoters of this service</a:t>
+                        <a:t>1000 subscribers in the AccelRR8 professional network who are net promoters of this service</a:t>
                       </a:r>
                     </a:p>
                   </a:txBody>
@@ -23909,7 +22450,7 @@
                       </a:r>
                       <a:r>
                         <a:rPr lang="en-US" dirty="0"/>
-                        <a:t>  becoming and remaining a collaborator must be incredibly easy</a:t>
+                        <a:t>  becoming and remaining a subscriber must be incredibly easy</a:t>
                       </a:r>
                     </a:p>
                   </a:txBody>
@@ -24667,7 +23208,7 @@
           <p:nvPr>
             <p:extLst>
               <p:ext uri="{D42A27DB-BD31-4B8C-83A1-F6EECF244321}">
-                <p14:modId xmlns:p14="http://schemas.microsoft.com/office/powerpoint/2010/main" val="3148504841"/>
+                <p14:modId xmlns:p14="http://schemas.microsoft.com/office/powerpoint/2010/main" val="3620108967"/>
               </p:ext>
             </p:extLst>
           </p:nvPr>
@@ -24901,7 +23442,7 @@
                       </a:pPr>
                       <a:r>
                         <a:rPr lang="en-US" dirty="0"/>
-                        <a:t>       Do collaborators prefer this over other services?   13:  the “grow value exponentially at scale” skill is valued</a:t>
+                        <a:t>       Do subscribers prefer this over other services?   13:  the “grow value exponentially at scale” skill is valued</a:t>
                       </a:r>
                     </a:p>
                     <a:p>
@@ -25051,7 +23592,7 @@
                       </a:pPr>
                       <a:r>
                         <a:rPr lang="en-US" dirty="0"/>
-                        <a:t>       What is the current effect on collaborator satisfaction?   13:  collaborators want exposure</a:t>
+                        <a:t>       What is the current effect on subscriber satisfaction?   13:  collaborators want exposure</a:t>
                       </a:r>
                     </a:p>
                     <a:p>
@@ -25101,7 +23642,7 @@
                       </a:pPr>
                       <a:r>
                         <a:rPr lang="en-US" dirty="0"/>
-                        <a:t>       Reduces the risk of this or future delivery?   13:  critical mass of collaborators is needed for network effects</a:t>
+                        <a:t>       Reduces the risk of this or future delivery?   13:  critical mass of subscribers is needed for network effects</a:t>
                       </a:r>
                     </a:p>
                     <a:p>
@@ -25126,7 +23667,7 @@
                       </a:pPr>
                       <a:r>
                         <a:rPr lang="en-US" dirty="0"/>
-                        <a:t>       Is there value in the information we receive?  13:  willingness of collaborators to engage</a:t>
+                        <a:t>       Is there value in the information we receive?  13:  willingness of subscribers to engage</a:t>
                       </a:r>
                     </a:p>
                     <a:p>
@@ -25151,7 +23692,7 @@
                       </a:pPr>
                       <a:r>
                         <a:rPr lang="en-US" dirty="0"/>
-                        <a:t>       Enable new business opportunities?  13:  collaborators will learn about other Consortium services</a:t>
+                        <a:t>       Enable new business opportunities?  13:  subscribers will learn about other Consortium services</a:t>
                       </a:r>
                     </a:p>
                     <a:p>
@@ -25223,7 +23764,7 @@
                       </a:pPr>
                       <a:r>
                         <a:rPr lang="en-US" dirty="0"/>
-                        <a:t>      Leaders will need to personally engage 100+ initial collaborators (6 months);</a:t>
+                        <a:t>      Leaders will need to personally engage 100+ initial subscribers (6 months);</a:t>
                       </a:r>
                     </a:p>
                     <a:p>
@@ -25248,7 +23789,7 @@
                       </a:pPr>
                       <a:r>
                         <a:rPr lang="en-US" dirty="0"/>
-                        <a:t>      Each new collaborator will need to engage 10 additional collaborators (6 months)</a:t>
+                        <a:t>      Each new subscriber will need to engage 10 additional subscribers (6 months)</a:t>
                       </a:r>
                     </a:p>
                   </a:txBody>
@@ -27045,7 +25586,7 @@
           <p:nvPr>
             <p:extLst>
               <p:ext uri="{D42A27DB-BD31-4B8C-83A1-F6EECF244321}">
-                <p14:modId xmlns:p14="http://schemas.microsoft.com/office/powerpoint/2010/main" val="1550568875"/>
+                <p14:modId xmlns:p14="http://schemas.microsoft.com/office/powerpoint/2010/main" val="1142039925"/>
               </p:ext>
             </p:extLst>
           </p:nvPr>
@@ -27279,7 +25820,7 @@
                       </a:pPr>
                       <a:r>
                         <a:rPr lang="en-US" dirty="0"/>
-                        <a:t>       Do collaborators prefer this over other services?   13:  the “grow value exponentially at scale” skill is valued</a:t>
+                        <a:t>       Do subscribers prefer this over other services?   13:  the “grow value exponentially at scale” skill is valued</a:t>
                       </a:r>
                     </a:p>
                     <a:p>
@@ -27429,7 +25970,7 @@
                       </a:pPr>
                       <a:r>
                         <a:rPr lang="en-US" dirty="0"/>
-                        <a:t>       What is the current effect on collaborator satisfaction?   13:  collaborators want exposure</a:t>
+                        <a:t>       What is the current effect on subscriber satisfaction?   13:  subscribers want exposure</a:t>
                       </a:r>
                     </a:p>
                     <a:p>
@@ -27479,7 +26020,7 @@
                       </a:pPr>
                       <a:r>
                         <a:rPr lang="en-US" dirty="0"/>
-                        <a:t>       Reduces the risk of this or future delivery?   13:  critical mass of collaborators is needed for network effects</a:t>
+                        <a:t>       Reduces the risk of this or future delivery?   13:  critical mass of subscribers is needed for network effects</a:t>
                       </a:r>
                     </a:p>
                     <a:p>
@@ -27504,7 +26045,7 @@
                       </a:pPr>
                       <a:r>
                         <a:rPr lang="en-US" dirty="0"/>
-                        <a:t>       Is there value in the information we receive?  13:  willingness of collaborators to engage</a:t>
+                        <a:t>       Is there value in the information we receive?  13:  willingness of subscribers to engage</a:t>
                       </a:r>
                     </a:p>
                     <a:p>
@@ -27529,7 +26070,7 @@
                       </a:pPr>
                       <a:r>
                         <a:rPr lang="en-US" dirty="0"/>
-                        <a:t>       Enable new business opportunities?  13:  collaborators will learn about other Consortium services</a:t>
+                        <a:t>       Enable new business opportunities?  13:  subscribers will learn about other Consortium services</a:t>
                       </a:r>
                     </a:p>
                     <a:p>
@@ -27601,7 +26142,7 @@
                       </a:pPr>
                       <a:r>
                         <a:rPr lang="en-US" dirty="0"/>
-                        <a:t>      Leaders will need to personally engage 100+ initial collaborators (6 months);</a:t>
+                        <a:t>      Leaders will need to personally engage 100+ initial subscribers (6 months);</a:t>
                       </a:r>
                     </a:p>
                     <a:p>
@@ -27626,7 +26167,7 @@
                       </a:pPr>
                       <a:r>
                         <a:rPr lang="en-US" dirty="0"/>
-                        <a:t>      Each new collaborator will need to engage 10 additional collaborators (6 months)</a:t>
+                        <a:t>      Each new subscriber will need to engage 10 additional subscribers (6 months)</a:t>
                       </a:r>
                     </a:p>
                   </a:txBody>
@@ -27737,7 +26278,7 @@
           <p:nvPr>
             <p:extLst>
               <p:ext uri="{D42A27DB-BD31-4B8C-83A1-F6EECF244321}">
-                <p14:modId xmlns:p14="http://schemas.microsoft.com/office/powerpoint/2010/main" val="2061638541"/>
+                <p14:modId xmlns:p14="http://schemas.microsoft.com/office/powerpoint/2010/main" val="70459462"/>
               </p:ext>
             </p:extLst>
           </p:nvPr>
@@ -27879,7 +26420,7 @@
                           </a:solidFill>
                           <a:effectLst/>
                         </a:rPr>
-                        <a:t>Rich Reba</a:t>
+                        <a:t>Professional Networking Leader</a:t>
                       </a:r>
                     </a:p>
                   </a:txBody>
@@ -27940,34 +26481,7 @@
                           </a:solidFill>
                           <a:effectLst/>
                         </a:rPr>
-                        <a:t>Core Boosters:  Board Members, Sumo </a:t>
-                      </a:r>
-                      <a:r>
-                        <a:rPr lang="en-US" sz="1100" dirty="0" err="1">
-                          <a:solidFill>
-                            <a:schemeClr val="tx1"/>
-                          </a:solidFill>
-                          <a:effectLst/>
-                        </a:rPr>
-                        <a:t>Mitro</a:t>
-                      </a:r>
-                      <a:r>
-                        <a:rPr lang="en-US" sz="1100" dirty="0">
-                          <a:solidFill>
-                            <a:schemeClr val="tx1"/>
-                          </a:solidFill>
-                          <a:effectLst/>
-                        </a:rPr>
-                        <a:t>, Pete </a:t>
-                      </a:r>
-                      <a:r>
-                        <a:rPr lang="en-US" sz="1100" dirty="0" err="1">
-                          <a:solidFill>
-                            <a:schemeClr val="tx1"/>
-                          </a:solidFill>
-                          <a:effectLst/>
-                        </a:rPr>
-                        <a:t>Tseronis</a:t>
+                        <a:t>Core Boosters:  Board Members, Board Advisors</a:t>
                       </a:r>
                       <a:endParaRPr lang="en-US" sz="1100" dirty="0">
                         <a:solidFill>
@@ -28297,7 +26811,7 @@
                           <a:cs typeface="+mn-cs"/>
                           <a:sym typeface="Arial"/>
                         </a:rPr>
-                        <a:t>, value for all collaborators grows exponentially as their numbers grow linearly.</a:t>
+                        <a:t>, value for all subscribers grows exponentially as their numbers grow linearly.</a:t>
                       </a:r>
                     </a:p>
                   </a:txBody>
@@ -28385,7 +26899,7 @@
                           </a:solidFill>
                           <a:effectLst/>
                         </a:rPr>
-                        <a:t>Collaborators: </a:t>
+                        <a:t>Subscribers: </a:t>
                       </a:r>
                       <a:r>
                         <a:rPr lang="en-US" sz="1100" dirty="0">
@@ -28394,7 +26908,7 @@
                           </a:solidFill>
                           <a:effectLst/>
                         </a:rPr>
-                        <a:t>improve their professional network, skills, brand, and career opportunities as measured via survey of collaborators</a:t>
+                        <a:t>improve their professional network, skills, brand, and career opportunities as measured via survey of subscribers</a:t>
                       </a:r>
                       <a:br>
                         <a:rPr lang="en-US" sz="1100" dirty="0">
@@ -28464,7 +26978,7 @@
                           </a:solidFill>
                           <a:effectLst/>
                         </a:rPr>
-                        <a:t>) as measured via survey of collaborators</a:t>
+                        <a:t>) as measured via survey of subscribers</a:t>
                       </a:r>
                     </a:p>
                   </a:txBody>
@@ -28525,7 +27039,7 @@
                           </a:solidFill>
                           <a:effectLst/>
                         </a:rPr>
-                        <a:t>1000 collaborators </a:t>
+                        <a:t>1000 subscribers </a:t>
                       </a:r>
                       <a:br>
                         <a:rPr lang="en-US" sz="1100" dirty="0">
@@ -28559,7 +27073,7 @@
                           </a:solidFill>
                           <a:effectLst/>
                         </a:rPr>
-                        <a:t>- are Net Promoters of this service as measured via survey of collaborators.</a:t>
+                        <a:t>- are Net Promoters of this service as measured via survey of subscribers.</a:t>
                       </a:r>
                       <a:endParaRPr lang="en-US" sz="1100" dirty="0">
                         <a:solidFill>
@@ -29084,7 +27598,7 @@
           <p:nvPr>
             <p:extLst>
               <p:ext uri="{D42A27DB-BD31-4B8C-83A1-F6EECF244321}">
-                <p14:modId xmlns:p14="http://schemas.microsoft.com/office/powerpoint/2010/main" val="3803830857"/>
+                <p14:modId xmlns:p14="http://schemas.microsoft.com/office/powerpoint/2010/main" val="641872856"/>
               </p:ext>
             </p:extLst>
           </p:nvPr>
@@ -29171,7 +27685,7 @@
                           </a:solidFill>
                           <a:effectLst/>
                         </a:rPr>
-                        <a:t>Enterprising Tech Services leaders can join the AccelRR8 Consortium network as collaborators</a:t>
+                        <a:t>Enterprising Tech Services leaders can join the AccelRR8 Consortium network as subscribers</a:t>
                       </a:r>
                     </a:p>
                     <a:p>
@@ -29440,7 +27954,7 @@
                       </a:r>
                       <a:r>
                         <a:rPr lang="en-US" sz="1100" dirty="0"/>
-                        <a:t>:  becoming and remaining a collaborator must be incredibly easy</a:t>
+                        <a:t>:  becoming and remaining a subscriber must be incredibly easy</a:t>
                       </a:r>
                     </a:p>
                     <a:p>
@@ -29524,7 +28038,7 @@
                           </a:solidFill>
                           <a:effectLst/>
                         </a:rPr>
-                        <a:t>Enterprising Tech Services leaders simply click to identify as a network collaborator in the AccelRR8 Consortium’s free electronic platform</a:t>
+                        <a:t>Enterprising Tech Services leaders simply click to identify as a network subscriber in the AccelRR8 Consortium’s free electronic platform</a:t>
                       </a:r>
                       <a:endParaRPr lang="en-US" sz="1100" dirty="0">
                         <a:solidFill>
@@ -29596,7 +28110,7 @@
                           </a:solidFill>
                           <a:effectLst/>
                         </a:rPr>
-                        <a:t>Collaborators can learn about, and make connections directly with, each other</a:t>
+                        <a:t>Subscribers can learn about, and make connections directly with, each other</a:t>
                       </a:r>
                     </a:p>
                     <a:p>
@@ -29629,7 +28143,7 @@
                           <a:ea typeface="MS Mincho" panose="02020609040205080304" pitchFamily="49" charset="-128"/>
                           <a:cs typeface="Arial" panose="020B0604020202020204" pitchFamily="34" charset="0"/>
                         </a:rPr>
-                        <a:t>Consortium leaders can view analytics about network collaborators</a:t>
+                        <a:t>Consortium leaders can view analytics about network subscribers</a:t>
                       </a:r>
                       <a:endParaRPr lang="en-US" sz="1100" dirty="0">
                         <a:solidFill>
@@ -29719,7 +28233,7 @@
                           </a:solidFill>
                           <a:effectLst/>
                         </a:rPr>
-                        <a:t>MVP desirability, viability, feasibility, and sustainability were verified by the Board of Directors as well as a subset of Advisors and Initial Collaborators.</a:t>
+                        <a:t>MVP desirability, viability, feasibility, and sustainability were verified by the Board of Directors as well as a subset of Advisors and initial subscribers.</a:t>
                       </a:r>
                       <a:endParaRPr lang="en-US" sz="1100" b="0" i="0" u="none" strike="noStrike" cap="none" dirty="0">
                         <a:solidFill>

</xml_diff>